<commit_message>
Plantilla 2026 con diseños reutilizables y paquete corregido
Cuatro diseños con marcadores —Portada, Sección, Contenido y En blanco—
donde antes había un único DEFAULT vacío. El folio pasa a ser campo de
número de diapositiva. Se corrige el patrón de notas, que compartía tema
con el de diapositivas y hacía que PowerPoint pidiera reparar el archivo.

La gráfica no cambia y las imágenes se conservan byte a byte.
Detalle en guidelines/CMF-plantilla-2026.CAMBIOS.md
</commit_message>
<xml_diff>
--- a/guidelines/CMF-plantilla-2026.pptx
+++ b/guidelines/CMF-plantilla-2026.pptx
@@ -752,6 +752,1744 @@
 </p:sldLayout>
 </file>
 
+<file path=ppt/slideLayouts/slideLayout2.xml><?xml version="1.0" encoding="utf-8"?>
+<p:sldLayout xmlns:p="http://schemas.openxmlformats.org/presentationml/2006/main" xmlns:a="http://schemas.openxmlformats.org/drawingml/2006/main" xmlns:r="http://schemas.openxmlformats.org/officeDocument/2006/relationships" preserve="1" type="title">
+  <p:cSld name="CMF Portada">
+    <p:bg>
+      <p:bgPr>
+        <a:solidFill>
+          <a:srgbClr val="FFFFFF"/>
+        </a:solidFill>
+      </p:bgPr>
+    </p:bg>
+    <p:spTree>
+      <p:nvGrpSpPr>
+        <p:cNvPr id="1" name=""/>
+        <p:cNvGrpSpPr/>
+        <p:nvPr/>
+      </p:nvGrpSpPr>
+      <p:grpSpPr>
+        <a:xfrm>
+          <a:off x="0" y="0"/>
+          <a:ext cx="0" cy="0"/>
+          <a:chOff x="0" y="0"/>
+          <a:chExt cx="0" cy="0"/>
+        </a:xfrm>
+      </p:grpSpPr>
+      <p:sp>
+        <p:nvSpPr>
+          <p:cNvPr id="2" name="Shape 0"/>
+          <p:cNvSpPr/>
+          <p:nvPr/>
+        </p:nvSpPr>
+        <p:spPr>
+          <a:xfrm>
+            <a:off x="0" y="0"/>
+            <a:ext cx="18288000" cy="5600700"/>
+          </a:xfrm>
+          <a:prstGeom prst="rect">
+            <a:avLst/>
+          </a:prstGeom>
+          <a:solidFill>
+            <a:srgbClr val="162D56"/>
+          </a:solidFill>
+          <a:ln/>
+        </p:spPr>
+      </p:sp>
+      <p:pic>
+        <p:nvPicPr>
+          <p:cNvPr id="3" name="Image 0" descr="preencoded.png">    </p:cNvPr>
+          <p:cNvPicPr>
+            <a:picLocks noChangeAspect="1"/>
+          </p:cNvPicPr>
+          <p:nvPr/>
+        </p:nvPicPr>
+        <p:blipFill>
+          <a:blip r:embed="rId1"/>
+          <a:srcRect l="0" r="0" t="3330" b="3330"/>
+          <a:stretch/>
+        </p:blipFill>
+        <p:spPr>
+          <a:xfrm>
+            <a:off x="0" y="0"/>
+            <a:ext cx="18288000" cy="5600700"/>
+          </a:xfrm>
+          <a:prstGeom prst="rect">
+            <a:avLst/>
+          </a:prstGeom>
+        </p:spPr>
+      </p:pic>
+      <p:sp>
+        <p:nvSpPr>
+          <p:cNvPr id="4" name="Text 1"/>
+          <p:cNvSpPr/>
+          <p:nvPr>
+            <p:ph type="ctrTitle"/>
+          </p:nvPr>
+        </p:nvSpPr>
+        <p:spPr>
+          <a:xfrm>
+            <a:off x="1828800" y="5971032"/>
+            <a:ext cx="14630400" cy="1280160"/>
+          </a:xfrm>
+          <a:prstGeom prst="rect">
+            <a:avLst/>
+          </a:prstGeom>
+          <a:noFill/>
+          <a:ln/>
+        </p:spPr>
+        <p:txBody>
+          <a:bodyPr wrap="square" lIns="25400" tIns="25400" rIns="25400" bIns="25400" rtlCol="0" anchor="t">
+            <a:normAutofit/>
+          </a:bodyPr>
+          <a:lstStyle>
+            <a:lvl1pPr algn="ctr" indent="0" marL="0">
+              <a:lnSpc>
+                <a:spcPct val="98630"/>
+              </a:lnSpc>
+              <a:buNone/>
+              <a:defRPr sz="4500" b="1">
+                <a:solidFill>
+                  <a:srgbClr val="575756"/>
+                </a:solidFill>
+                <a:latin typeface="Verdana" pitchFamily="34" charset="0"/>
+                <a:ea typeface="Verdana" pitchFamily="34" charset="-122"/>
+                <a:cs typeface="Verdana" pitchFamily="34" charset="-120"/>
+              </a:defRPr>
+            </a:lvl1pPr>
+          </a:lstStyle>
+          <a:p>
+            <a:pPr algn="ctr" indent="0" marL="0">
+              <a:lnSpc>
+                <a:spcPct val="98630"/>
+              </a:lnSpc>
+              <a:buNone/>
+            </a:pPr>
+            <a:r>
+              <a:rPr lang="en-US" sz="4500" b="1" spc="-45" kern="0" dirty="0">
+                <a:solidFill>
+                  <a:srgbClr val="575756"/>
+                </a:solidFill>
+                <a:latin typeface="Verdana" pitchFamily="34" charset="0"/>
+                <a:ea typeface="Verdana" pitchFamily="34" charset="-122"/>
+                <a:cs typeface="Verdana" pitchFamily="34" charset="-120"/>
+              </a:rPr>
+              <a:t>Título de la presentación</a:t>
+            </a:r>
+            <a:endParaRPr lang="en-US" sz="4500" dirty="0"/>
+          </a:p>
+        </p:txBody>
+      </p:sp>
+      <p:sp>
+        <p:nvSpPr>
+          <p:cNvPr id="5" name="Text 2"/>
+          <p:cNvSpPr/>
+          <p:nvPr>
+            <p:ph type="subTitle" idx="1"/>
+          </p:nvPr>
+        </p:nvSpPr>
+        <p:spPr>
+          <a:xfrm>
+            <a:off x="1828800" y="7424928"/>
+            <a:ext cx="14630400" cy="512064"/>
+          </a:xfrm>
+          <a:prstGeom prst="rect">
+            <a:avLst/>
+          </a:prstGeom>
+          <a:noFill/>
+          <a:ln/>
+        </p:spPr>
+        <p:txBody>
+          <a:bodyPr wrap="square" lIns="25400" tIns="25400" rIns="25400" bIns="25400" rtlCol="0" anchor="t">
+            <a:normAutofit/>
+          </a:bodyPr>
+          <a:lstStyle>
+            <a:lvl1pPr algn="ctr" indent="0" marL="0">
+              <a:lnSpc>
+                <a:spcPct val="123750"/>
+              </a:lnSpc>
+              <a:buNone/>
+              <a:defRPr sz="2475" b="1">
+                <a:solidFill>
+                  <a:srgbClr val="2C2C2B"/>
+                </a:solidFill>
+                <a:latin typeface="Verdana" pitchFamily="34" charset="0"/>
+                <a:ea typeface="Verdana" pitchFamily="34" charset="-122"/>
+                <a:cs typeface="Verdana" pitchFamily="34" charset="-120"/>
+              </a:defRPr>
+            </a:lvl1pPr>
+          </a:lstStyle>
+          <a:p>
+            <a:pPr algn="ctr" indent="0" marL="0">
+              <a:lnSpc>
+                <a:spcPct val="123750"/>
+              </a:lnSpc>
+              <a:buNone/>
+            </a:pPr>
+            <a:r>
+              <a:rPr lang="en-US" sz="2475" b="1" dirty="0">
+                <a:solidFill>
+                  <a:srgbClr val="2C2C2B"/>
+                </a:solidFill>
+                <a:latin typeface="Verdana" pitchFamily="34" charset="0"/>
+                <a:ea typeface="Verdana" pitchFamily="34" charset="-122"/>
+                <a:cs typeface="Verdana" pitchFamily="34" charset="-120"/>
+              </a:rPr>
+              <a:t>Nombre Apellido</a:t>
+            </a:r>
+            <a:endParaRPr lang="en-US" sz="2475" dirty="0"/>
+          </a:p>
+        </p:txBody>
+      </p:sp>
+      <p:sp>
+        <p:nvSpPr>
+          <p:cNvPr id="6" name="Text 3"/>
+          <p:cNvSpPr/>
+          <p:nvPr>
+            <p:ph type="body" idx="2"/>
+          </p:nvPr>
+        </p:nvSpPr>
+        <p:spPr>
+          <a:xfrm>
+            <a:off x="1828800" y="7955280"/>
+            <a:ext cx="14630400" cy="621792"/>
+          </a:xfrm>
+          <a:prstGeom prst="rect">
+            <a:avLst/>
+          </a:prstGeom>
+          <a:noFill/>
+          <a:ln/>
+        </p:spPr>
+        <p:txBody>
+          <a:bodyPr wrap="square" lIns="25400" tIns="25400" rIns="25400" bIns="25400" rtlCol="0" anchor="t">
+            <a:normAutofit/>
+          </a:bodyPr>
+          <a:lstStyle>
+            <a:lvl1pPr algn="ctr" indent="0" marL="0">
+              <a:lnSpc>
+                <a:spcPct val="121800"/>
+              </a:lnSpc>
+              <a:buNone/>
+              <a:defRPr sz="1575">
+                <a:solidFill>
+                  <a:srgbClr val="575756"/>
+                </a:solidFill>
+                <a:latin typeface="Verdana" pitchFamily="34" charset="0"/>
+                <a:ea typeface="Verdana" pitchFamily="34" charset="-122"/>
+                <a:cs typeface="Verdana" pitchFamily="34" charset="-120"/>
+              </a:defRPr>
+            </a:lvl1pPr>
+          </a:lstStyle>
+          <a:p>
+            <a:pPr algn="ctr" indent="0" marL="0">
+              <a:lnSpc>
+                <a:spcPct val="121800"/>
+              </a:lnSpc>
+              <a:buNone/>
+            </a:pPr>
+            <a:r>
+              <a:rPr lang="en-US" sz="1575" dirty="0">
+                <a:solidFill>
+                  <a:srgbClr val="575756"/>
+                </a:solidFill>
+                <a:latin typeface="Verdana" pitchFamily="34" charset="0"/>
+                <a:ea typeface="Verdana" pitchFamily="34" charset="-122"/>
+                <a:cs typeface="Verdana" pitchFamily="34" charset="-120"/>
+              </a:rPr>
+              <a:t>Cargo / Dirección Comisión para el Mercado Financiero</a:t>
+            </a:r>
+            <a:endParaRPr lang="en-US" sz="1575" dirty="0"/>
+          </a:p>
+        </p:txBody>
+      </p:sp>
+      <p:sp>
+        <p:nvSpPr>
+          <p:cNvPr id="7" name="Text 4"/>
+          <p:cNvSpPr/>
+          <p:nvPr>
+            <p:ph type="body" idx="3"/>
+          </p:nvPr>
+        </p:nvSpPr>
+        <p:spPr>
+          <a:xfrm>
+            <a:off x="1828800" y="8933688"/>
+            <a:ext cx="14630400" cy="365760"/>
+          </a:xfrm>
+          <a:prstGeom prst="rect">
+            <a:avLst/>
+          </a:prstGeom>
+          <a:noFill/>
+          <a:ln/>
+        </p:spPr>
+        <p:txBody>
+          <a:bodyPr wrap="square" lIns="25400" tIns="25400" rIns="25400" bIns="25400" rtlCol="0" anchor="t">
+            <a:normAutofit/>
+          </a:bodyPr>
+          <a:lstStyle>
+            <a:lvl1pPr algn="ctr" indent="0" marL="0">
+              <a:lnSpc>
+                <a:spcPct val="123214"/>
+              </a:lnSpc>
+              <a:buNone/>
+              <a:defRPr sz="1725" b="1">
+                <a:solidFill>
+                  <a:srgbClr val="575756"/>
+                </a:solidFill>
+                <a:latin typeface="Verdana" pitchFamily="34" charset="0"/>
+                <a:ea typeface="Verdana" pitchFamily="34" charset="-122"/>
+                <a:cs typeface="Verdana" pitchFamily="34" charset="-120"/>
+              </a:defRPr>
+            </a:lvl1pPr>
+          </a:lstStyle>
+          <a:p>
+            <a:pPr algn="ctr" indent="0" marL="0">
+              <a:lnSpc>
+                <a:spcPct val="123214"/>
+              </a:lnSpc>
+              <a:buNone/>
+            </a:pPr>
+            <a:r>
+              <a:rPr lang="en-US" sz="1725" b="1" dirty="0">
+                <a:solidFill>
+                  <a:srgbClr val="575756"/>
+                </a:solidFill>
+                <a:latin typeface="Verdana" pitchFamily="34" charset="0"/>
+                <a:ea typeface="Verdana" pitchFamily="34" charset="-122"/>
+                <a:cs typeface="Verdana" pitchFamily="34" charset="-120"/>
+              </a:rPr>
+              <a:t>Marzo 2026</a:t>
+            </a:r>
+            <a:endParaRPr lang="en-US" sz="1725" dirty="0"/>
+          </a:p>
+        </p:txBody>
+      </p:sp>
+      <p:sp>
+        <p:nvSpPr>
+          <p:cNvPr id="8" name="Shape 5"/>
+          <p:cNvSpPr/>
+          <p:nvPr/>
+        </p:nvSpPr>
+        <p:spPr>
+          <a:xfrm>
+            <a:off x="0" y="9629775"/>
+            <a:ext cx="18288000" cy="657225"/>
+          </a:xfrm>
+          <a:prstGeom prst="rect">
+            <a:avLst/>
+          </a:prstGeom>
+          <a:solidFill>
+            <a:srgbClr val="112351"/>
+          </a:solidFill>
+          <a:ln/>
+        </p:spPr>
+      </p:sp>
+      <p:pic>
+        <p:nvPicPr>
+          <p:cNvPr id="9" name="Image 1" descr="preencoded.png">    </p:cNvPr>
+          <p:cNvPicPr>
+            <a:picLocks noChangeAspect="1"/>
+          </p:cNvPicPr>
+          <p:nvPr/>
+        </p:nvPicPr>
+        <p:blipFill>
+          <a:blip r:embed="rId2"/>
+          <a:srcRect l="0" r="0" t="11564" b="11564"/>
+          <a:stretch/>
+        </p:blipFill>
+        <p:spPr>
+          <a:xfrm>
+            <a:off x="0" y="9629775"/>
+            <a:ext cx="18288000" cy="657225"/>
+          </a:xfrm>
+          <a:prstGeom prst="rect">
+            <a:avLst/>
+          </a:prstGeom>
+        </p:spPr>
+      </p:pic>
+      <p:sp>
+        <p:nvSpPr>
+          <p:cNvPr id="10" name="Text 6"/>
+          <p:cNvSpPr/>
+          <p:nvPr>
+            <p:ph type="sldNum" idx="10"/>
+          </p:nvPr>
+        </p:nvSpPr>
+        <p:spPr>
+          <a:xfrm>
+            <a:off x="16002000" y="9848088"/>
+            <a:ext cx="1371600" cy="265176"/>
+          </a:xfrm>
+          <a:prstGeom prst="rect">
+            <a:avLst/>
+          </a:prstGeom>
+          <a:noFill/>
+          <a:ln/>
+        </p:spPr>
+        <p:txBody>
+          <a:bodyPr wrap="square" lIns="25400" tIns="25400" rIns="25400" bIns="25400" rtlCol="0" anchor="t">
+            <a:normAutofit/>
+          </a:bodyPr>
+          <a:lstStyle>
+            <a:lvl1pPr algn="r" indent="0" marL="0">
+              <a:lnSpc>
+                <a:spcPct val="109091"/>
+              </a:lnSpc>
+              <a:buNone/>
+              <a:defRPr sz="1200">
+                <a:solidFill>
+                  <a:srgbClr val="FFFFFF">
+                    <a:alpha val="85000"/>
+                  </a:srgbClr>
+                </a:solidFill>
+                <a:latin typeface="Source Sans 3" pitchFamily="34" charset="0"/>
+                <a:ea typeface="Source Sans 3" pitchFamily="34" charset="-122"/>
+                <a:cs typeface="Source Sans 3" pitchFamily="34" charset="-120"/>
+              </a:defRPr>
+            </a:lvl1pPr>
+          </a:lstStyle>
+          <a:p>
+            <a:pPr algn="r" indent="0" marL="0">
+              <a:lnSpc>
+                <a:spcPct val="109091"/>
+              </a:lnSpc>
+              <a:buNone/>
+            </a:pPr>
+            <a:fld id="{B5E4E44B-B729-4933-9576-2397FE414F70}" type="slidenum">
+              <a:rPr lang="en-US" sz="1200" dirty="0">
+                <a:solidFill>
+                  <a:srgbClr val="FFFFFF">
+                    <a:alpha val="85000"/>
+                  </a:srgbClr>
+                </a:solidFill>
+                <a:latin typeface="Source Sans 3" pitchFamily="34" charset="0"/>
+                <a:ea typeface="Source Sans 3" pitchFamily="34" charset="-122"/>
+                <a:cs typeface="Source Sans 3" pitchFamily="34" charset="-120"/>
+              </a:rPr>
+              <a:t>1</a:t>
+            </a:fld>
+            <a:endParaRPr lang="en-US" sz="1200" dirty="0"/>
+          </a:p>
+        </p:txBody>
+      </p:sp>
+    </p:spTree>
+  </p:cSld>
+  <p:clrMapOvr>
+    <a:masterClrMapping/>
+  </p:clrMapOvr>
+</p:sldLayout>
+</file>
+
+<file path=ppt/slideLayouts/slideLayout3.xml><?xml version="1.0" encoding="utf-8"?>
+<p:sldLayout xmlns:p="http://schemas.openxmlformats.org/presentationml/2006/main" xmlns:a="http://schemas.openxmlformats.org/drawingml/2006/main" xmlns:r="http://schemas.openxmlformats.org/officeDocument/2006/relationships" preserve="1" type="secHead">
+  <p:cSld name="CMF Sección">
+    <p:bg>
+      <p:bgPr>
+        <a:solidFill>
+          <a:srgbClr val="FFFFFF"/>
+        </a:solidFill>
+      </p:bgPr>
+    </p:bg>
+    <p:spTree>
+      <p:nvGrpSpPr>
+        <p:cNvPr id="1" name=""/>
+        <p:cNvGrpSpPr/>
+        <p:nvPr/>
+      </p:nvGrpSpPr>
+      <p:grpSpPr>
+        <a:xfrm>
+          <a:off x="0" y="0"/>
+          <a:ext cx="0" cy="0"/>
+          <a:chOff x="0" y="0"/>
+          <a:chExt cx="0" cy="0"/>
+        </a:xfrm>
+      </p:grpSpPr>
+      <p:sp>
+        <p:nvSpPr>
+          <p:cNvPr id="2" name="Shape 0"/>
+          <p:cNvSpPr/>
+          <p:nvPr/>
+        </p:nvSpPr>
+        <p:spPr>
+          <a:xfrm>
+            <a:off x="0" y="0"/>
+            <a:ext cx="18288000" cy="114300"/>
+          </a:xfrm>
+          <a:prstGeom prst="rect">
+            <a:avLst/>
+          </a:prstGeom>
+          <a:solidFill>
+            <a:srgbClr val="5B2B82"/>
+          </a:solidFill>
+          <a:ln/>
+        </p:spPr>
+      </p:sp>
+      <p:sp>
+        <p:nvSpPr>
+          <p:cNvPr id="3" name="Text 1"/>
+          <p:cNvSpPr/>
+          <p:nvPr>
+            <p:ph type="body" idx="1"/>
+          </p:nvPr>
+        </p:nvSpPr>
+        <p:spPr>
+          <a:xfrm>
+            <a:off x="914400" y="640080"/>
+            <a:ext cx="16459200" cy="338328"/>
+          </a:xfrm>
+          <a:prstGeom prst="rect">
+            <a:avLst/>
+          </a:prstGeom>
+          <a:noFill/>
+          <a:ln/>
+        </p:spPr>
+        <p:txBody>
+          <a:bodyPr wrap="square" lIns="25400" tIns="25400" rIns="25400" bIns="25400" rtlCol="0" anchor="t">
+            <a:normAutofit/>
+          </a:bodyPr>
+          <a:lstStyle>
+            <a:lvl1pPr algn="l" indent="0" marL="0">
+              <a:lnSpc>
+                <a:spcPct val="105000"/>
+              </a:lnSpc>
+              <a:buNone/>
+              <a:defRPr sz="1575" b="1">
+                <a:solidFill>
+                  <a:srgbClr val="8547AD"/>
+                </a:solidFill>
+                <a:latin typeface="Source Sans 3" pitchFamily="34" charset="0"/>
+                <a:ea typeface="Source Sans 3" pitchFamily="34" charset="-122"/>
+                <a:cs typeface="Source Sans 3" pitchFamily="34" charset="-120"/>
+              </a:defRPr>
+            </a:lvl1pPr>
+          </a:lstStyle>
+          <a:p>
+            <a:pPr algn="l" indent="0" marL="0">
+              <a:lnSpc>
+                <a:spcPct val="105000"/>
+              </a:lnSpc>
+              <a:buNone/>
+            </a:pPr>
+            <a:r>
+              <a:rPr lang="en-US" sz="1575" b="1" spc="126" kern="0" dirty="0">
+                <a:solidFill>
+                  <a:srgbClr val="8547AD"/>
+                </a:solidFill>
+                <a:latin typeface="Source Sans 3" pitchFamily="34" charset="0"/>
+                <a:ea typeface="Source Sans 3" pitchFamily="34" charset="-122"/>
+                <a:cs typeface="Source Sans 3" pitchFamily="34" charset="-120"/>
+              </a:rPr>
+              <a:t>ANTETÍTULO DE SECCIÓN</a:t>
+            </a:r>
+            <a:endParaRPr lang="en-US" sz="1575" dirty="0"/>
+          </a:p>
+        </p:txBody>
+      </p:sp>
+      <p:pic>
+        <p:nvPicPr>
+          <p:cNvPr id="4" name="Image 0" descr="preencoded.png">    </p:cNvPr>
+          <p:cNvPicPr>
+            <a:picLocks noChangeAspect="1"/>
+          </p:cNvPicPr>
+          <p:nvPr/>
+        </p:nvPicPr>
+        <p:blipFill>
+          <a:blip r:embed="rId1"/>
+          <a:stretch>
+            <a:fillRect/>
+          </a:stretch>
+        </p:blipFill>
+        <p:spPr>
+          <a:xfrm>
+            <a:off x="15772656" y="542925"/>
+            <a:ext cx="1600944" cy="485775"/>
+          </a:xfrm>
+          <a:prstGeom prst="rect">
+            <a:avLst/>
+          </a:prstGeom>
+        </p:spPr>
+      </p:pic>
+      <p:sp>
+        <p:nvSpPr>
+          <p:cNvPr id="5" name="Text 2"/>
+          <p:cNvSpPr/>
+          <p:nvPr>
+            <p:ph type="title"/>
+          </p:nvPr>
+        </p:nvSpPr>
+        <p:spPr>
+          <a:xfrm>
+            <a:off x="914400" y="1197864"/>
+            <a:ext cx="16459200" cy="822960"/>
+          </a:xfrm>
+          <a:prstGeom prst="rect">
+            <a:avLst/>
+          </a:prstGeom>
+          <a:noFill/>
+          <a:ln/>
+        </p:spPr>
+        <p:txBody>
+          <a:bodyPr wrap="square" lIns="25400" tIns="25400" rIns="25400" bIns="25400" rtlCol="0" anchor="t">
+            <a:normAutofit/>
+          </a:bodyPr>
+          <a:lstStyle>
+            <a:lvl1pPr algn="l" indent="0" marL="0">
+              <a:lnSpc>
+                <a:spcPct val="95000"/>
+              </a:lnSpc>
+              <a:buNone/>
+              <a:defRPr sz="4275" b="1">
+                <a:solidFill>
+                  <a:srgbClr val="575756"/>
+                </a:solidFill>
+                <a:latin typeface="Verdana" pitchFamily="34" charset="0"/>
+                <a:ea typeface="Verdana" pitchFamily="34" charset="-122"/>
+                <a:cs typeface="Verdana" pitchFamily="34" charset="-120"/>
+              </a:defRPr>
+            </a:lvl1pPr>
+          </a:lstStyle>
+          <a:p>
+            <a:pPr algn="l" indent="0" marL="0">
+              <a:lnSpc>
+                <a:spcPct val="95000"/>
+              </a:lnSpc>
+              <a:buNone/>
+            </a:pPr>
+            <a:r>
+              <a:rPr lang="en-US" sz="4275" b="1" spc="-43" kern="0" dirty="0">
+                <a:solidFill>
+                  <a:srgbClr val="575756"/>
+                </a:solidFill>
+                <a:latin typeface="Verdana" pitchFamily="34" charset="0"/>
+                <a:ea typeface="Verdana" pitchFamily="34" charset="-122"/>
+                <a:cs typeface="Verdana" pitchFamily="34" charset="-120"/>
+              </a:rPr>
+              <a:t>Título de la diapositiva</a:t>
+            </a:r>
+            <a:endParaRPr lang="en-US" sz="4275" dirty="0"/>
+          </a:p>
+        </p:txBody>
+      </p:sp>
+      <p:sp>
+        <p:nvSpPr>
+          <p:cNvPr id="6" name="Shape 3"/>
+          <p:cNvSpPr/>
+          <p:nvPr/>
+        </p:nvSpPr>
+        <p:spPr>
+          <a:xfrm>
+            <a:off x="914400" y="2138809"/>
+            <a:ext cx="914400" cy="76200"/>
+          </a:xfrm>
+          <a:prstGeom prst="roundRect">
+            <a:avLst>
+              <a:gd name="adj" fmla="val 50000"/>
+            </a:avLst>
+          </a:prstGeom>
+          <a:solidFill>
+            <a:srgbClr val="5B2B82"/>
+          </a:solidFill>
+          <a:ln/>
+        </p:spPr>
+      </p:sp>
+      <p:sp>
+        <p:nvSpPr>
+          <p:cNvPr id="15" name="Shape 12"/>
+          <p:cNvSpPr/>
+          <p:nvPr/>
+        </p:nvSpPr>
+        <p:spPr>
+          <a:xfrm>
+            <a:off x="914400" y="9534525"/>
+            <a:ext cx="16459200" cy="9525"/>
+          </a:xfrm>
+          <a:prstGeom prst="rect">
+            <a:avLst/>
+          </a:prstGeom>
+          <a:solidFill>
+            <a:srgbClr val="D7D7D6"/>
+          </a:solidFill>
+          <a:ln/>
+        </p:spPr>
+      </p:sp>
+      <p:pic>
+        <p:nvPicPr>
+          <p:cNvPr id="16" name="Image 1" descr="preencoded.png">    </p:cNvPr>
+          <p:cNvPicPr>
+            <a:picLocks noChangeAspect="1"/>
+          </p:cNvPicPr>
+          <p:nvPr/>
+        </p:nvPicPr>
+        <p:blipFill>
+          <a:blip r:embed="rId2"/>
+          <a:stretch>
+            <a:fillRect/>
+          </a:stretch>
+        </p:blipFill>
+        <p:spPr>
+          <a:xfrm>
+            <a:off x="914400" y="9729788"/>
+            <a:ext cx="240804" cy="228600"/>
+          </a:xfrm>
+          <a:prstGeom prst="rect">
+            <a:avLst/>
+          </a:prstGeom>
+        </p:spPr>
+      </p:pic>
+      <p:sp>
+        <p:nvSpPr>
+          <p:cNvPr id="17" name="Text 13"/>
+          <p:cNvSpPr/>
+          <p:nvPr/>
+        </p:nvSpPr>
+        <p:spPr>
+          <a:xfrm>
+            <a:off x="1289304" y="9729216"/>
+            <a:ext cx="7315200" cy="274320"/>
+          </a:xfrm>
+          <a:prstGeom prst="rect">
+            <a:avLst/>
+          </a:prstGeom>
+          <a:noFill/>
+          <a:ln/>
+        </p:spPr>
+        <p:txBody>
+          <a:bodyPr wrap="square" lIns="0" tIns="0" rIns="0" bIns="0" rtlCol="0" anchor="t">
+            <a:normAutofit/>
+          </a:bodyPr>
+          <a:lstStyle/>
+          <a:p>
+            <a:pPr algn="l" indent="0" marL="0">
+              <a:lnSpc>
+                <a:spcPct val="108000"/>
+              </a:lnSpc>
+              <a:buNone/>
+            </a:pPr>
+            <a:r>
+              <a:rPr lang="en-US" sz="1350" dirty="0">
+                <a:solidFill>
+                  <a:srgbClr val="969695"/>
+                </a:solidFill>
+                <a:latin typeface="Source Sans 3" pitchFamily="34" charset="0"/>
+                <a:ea typeface="Source Sans 3" pitchFamily="34" charset="-122"/>
+                <a:cs typeface="Source Sans 3" pitchFamily="34" charset="-120"/>
+              </a:rPr>
+              <a:t>Comisión para el Mercado Financiero</a:t>
+            </a:r>
+            <a:endParaRPr lang="en-US" sz="1350" dirty="0"/>
+          </a:p>
+        </p:txBody>
+      </p:sp>
+      <p:sp>
+        <p:nvSpPr>
+          <p:cNvPr id="18" name="Text 14"/>
+          <p:cNvSpPr/>
+          <p:nvPr/>
+        </p:nvSpPr>
+        <p:spPr>
+          <a:xfrm>
+            <a:off x="11887200" y="9710928"/>
+            <a:ext cx="5486400" cy="292608"/>
+          </a:xfrm>
+          <a:prstGeom prst="rect">
+            <a:avLst/>
+          </a:prstGeom>
+          <a:noFill/>
+          <a:ln/>
+        </p:spPr>
+        <p:txBody>
+          <a:bodyPr wrap="square" lIns="25400" tIns="25400" rIns="25400" bIns="25400" rtlCol="0" anchor="t">
+            <a:normAutofit/>
+          </a:bodyPr>
+          <a:lstStyle/>
+          <a:p>
+            <a:pPr algn="r" indent="0" marL="0">
+              <a:lnSpc>
+                <a:spcPct val="108000"/>
+              </a:lnSpc>
+              <a:buNone/>
+            </a:pPr>
+            <a:r>
+              <a:rPr lang="en-US" sz="1350" dirty="0">
+                <a:solidFill>
+                  <a:srgbClr val="969695"/>
+                </a:solidFill>
+                <a:latin typeface="Source Sans 3" pitchFamily="34" charset="0"/>
+                <a:ea typeface="Source Sans 3" pitchFamily="34" charset="-122"/>
+                <a:cs typeface="Source Sans 3" pitchFamily="34" charset="-120"/>
+              </a:rPr>
+              <a:t>Marzo 2026 · </a:t>
+            </a:r>
+            <a:fld id="{296237B6-5E3F-4A53-8617-0B6476DA17E1}" type="slidenum">
+              <a:rPr lang="en-US" sz="1350" dirty="0">
+                <a:solidFill>
+                  <a:srgbClr val="969695"/>
+                </a:solidFill>
+                <a:latin typeface="Source Sans 3" pitchFamily="34" charset="0"/>
+                <a:ea typeface="Source Sans 3" pitchFamily="34" charset="-122"/>
+                <a:cs typeface="Source Sans 3" pitchFamily="34" charset="-120"/>
+              </a:rPr>
+              <a:t>3</a:t>
+            </a:fld>
+            <a:endParaRPr lang="en-US" sz="1350" dirty="0"/>
+          </a:p>
+        </p:txBody>
+      </p:sp>
+    </p:spTree>
+  </p:cSld>
+  <p:clrMapOvr>
+    <a:masterClrMapping/>
+  </p:clrMapOvr>
+</p:sldLayout>
+</file>
+
+<file path=ppt/slideLayouts/slideLayout4.xml><?xml version="1.0" encoding="utf-8"?>
+<p:sldLayout xmlns:p="http://schemas.openxmlformats.org/presentationml/2006/main" xmlns:a="http://schemas.openxmlformats.org/drawingml/2006/main" xmlns:r="http://schemas.openxmlformats.org/officeDocument/2006/relationships" preserve="1" type="obj">
+  <p:cSld name="CMF Contenido">
+    <p:bg>
+      <p:bgPr>
+        <a:solidFill>
+          <a:srgbClr val="FFFFFF"/>
+        </a:solidFill>
+      </p:bgPr>
+    </p:bg>
+    <p:spTree>
+      <p:nvGrpSpPr>
+        <p:cNvPr id="1" name=""/>
+        <p:cNvGrpSpPr/>
+        <p:nvPr/>
+      </p:nvGrpSpPr>
+      <p:grpSpPr>
+        <a:xfrm>
+          <a:off x="0" y="0"/>
+          <a:ext cx="0" cy="0"/>
+          <a:chOff x="0" y="0"/>
+          <a:chExt cx="0" cy="0"/>
+        </a:xfrm>
+      </p:grpSpPr>
+      <p:sp>
+        <p:nvSpPr>
+          <p:cNvPr id="2" name="Shape 0"/>
+          <p:cNvSpPr/>
+          <p:nvPr/>
+        </p:nvSpPr>
+        <p:spPr>
+          <a:xfrm>
+            <a:off x="0" y="0"/>
+            <a:ext cx="18288000" cy="114300"/>
+          </a:xfrm>
+          <a:prstGeom prst="rect">
+            <a:avLst/>
+          </a:prstGeom>
+          <a:solidFill>
+            <a:srgbClr val="5B2B82"/>
+          </a:solidFill>
+          <a:ln/>
+        </p:spPr>
+      </p:sp>
+      <p:sp>
+        <p:nvSpPr>
+          <p:cNvPr id="3" name="Text 1"/>
+          <p:cNvSpPr/>
+          <p:nvPr>
+            <p:ph type="body" idx="1"/>
+          </p:nvPr>
+        </p:nvSpPr>
+        <p:spPr>
+          <a:xfrm>
+            <a:off x="914400" y="640080"/>
+            <a:ext cx="16459200" cy="338328"/>
+          </a:xfrm>
+          <a:prstGeom prst="rect">
+            <a:avLst/>
+          </a:prstGeom>
+          <a:noFill/>
+          <a:ln/>
+        </p:spPr>
+        <p:txBody>
+          <a:bodyPr wrap="square" lIns="25400" tIns="25400" rIns="25400" bIns="25400" rtlCol="0" anchor="t">
+            <a:normAutofit/>
+          </a:bodyPr>
+          <a:lstStyle>
+            <a:lvl1pPr algn="l" indent="0" marL="0">
+              <a:lnSpc>
+                <a:spcPct val="105000"/>
+              </a:lnSpc>
+              <a:buNone/>
+              <a:defRPr sz="1575" b="1">
+                <a:solidFill>
+                  <a:srgbClr val="8547AD"/>
+                </a:solidFill>
+                <a:latin typeface="Source Sans 3" pitchFamily="34" charset="0"/>
+                <a:ea typeface="Source Sans 3" pitchFamily="34" charset="-122"/>
+                <a:cs typeface="Source Sans 3" pitchFamily="34" charset="-120"/>
+              </a:defRPr>
+            </a:lvl1pPr>
+          </a:lstStyle>
+          <a:p>
+            <a:pPr algn="l" indent="0" marL="0">
+              <a:lnSpc>
+                <a:spcPct val="105000"/>
+              </a:lnSpc>
+              <a:buNone/>
+            </a:pPr>
+            <a:r>
+              <a:rPr lang="en-US" sz="1575" b="1" spc="126" kern="0" dirty="0">
+                <a:solidFill>
+                  <a:srgbClr val="8547AD"/>
+                </a:solidFill>
+                <a:latin typeface="Source Sans 3" pitchFamily="34" charset="0"/>
+                <a:ea typeface="Source Sans 3" pitchFamily="34" charset="-122"/>
+                <a:cs typeface="Source Sans 3" pitchFamily="34" charset="-120"/>
+              </a:rPr>
+              <a:t>ANTETÍTULO DE SECCIÓN</a:t>
+            </a:r>
+            <a:endParaRPr lang="en-US" sz="1575" dirty="0"/>
+          </a:p>
+        </p:txBody>
+      </p:sp>
+      <p:pic>
+        <p:nvPicPr>
+          <p:cNvPr id="4" name="Image 0" descr="preencoded.png">    </p:cNvPr>
+          <p:cNvPicPr>
+            <a:picLocks noChangeAspect="1"/>
+          </p:cNvPicPr>
+          <p:nvPr/>
+        </p:nvPicPr>
+        <p:blipFill>
+          <a:blip r:embed="rId1"/>
+          <a:stretch>
+            <a:fillRect/>
+          </a:stretch>
+        </p:blipFill>
+        <p:spPr>
+          <a:xfrm>
+            <a:off x="15772656" y="542925"/>
+            <a:ext cx="1600944" cy="485775"/>
+          </a:xfrm>
+          <a:prstGeom prst="rect">
+            <a:avLst/>
+          </a:prstGeom>
+        </p:spPr>
+      </p:pic>
+      <p:sp>
+        <p:nvSpPr>
+          <p:cNvPr id="5" name="Text 2"/>
+          <p:cNvSpPr/>
+          <p:nvPr>
+            <p:ph type="title"/>
+          </p:nvPr>
+        </p:nvSpPr>
+        <p:spPr>
+          <a:xfrm>
+            <a:off x="914400" y="1197864"/>
+            <a:ext cx="16459200" cy="822960"/>
+          </a:xfrm>
+          <a:prstGeom prst="rect">
+            <a:avLst/>
+          </a:prstGeom>
+          <a:noFill/>
+          <a:ln/>
+        </p:spPr>
+        <p:txBody>
+          <a:bodyPr wrap="square" lIns="25400" tIns="25400" rIns="25400" bIns="25400" rtlCol="0" anchor="t">
+            <a:normAutofit/>
+          </a:bodyPr>
+          <a:lstStyle>
+            <a:lvl1pPr algn="l" indent="0" marL="0">
+              <a:lnSpc>
+                <a:spcPct val="95000"/>
+              </a:lnSpc>
+              <a:buNone/>
+              <a:defRPr sz="4275" b="1">
+                <a:solidFill>
+                  <a:srgbClr val="575756"/>
+                </a:solidFill>
+                <a:latin typeface="Verdana" pitchFamily="34" charset="0"/>
+                <a:ea typeface="Verdana" pitchFamily="34" charset="-122"/>
+                <a:cs typeface="Verdana" pitchFamily="34" charset="-120"/>
+              </a:defRPr>
+            </a:lvl1pPr>
+          </a:lstStyle>
+          <a:p>
+            <a:pPr algn="l" indent="0" marL="0">
+              <a:lnSpc>
+                <a:spcPct val="95000"/>
+              </a:lnSpc>
+              <a:buNone/>
+            </a:pPr>
+            <a:r>
+              <a:rPr lang="en-US" sz="4275" b="1" spc="-43" kern="0" dirty="0">
+                <a:solidFill>
+                  <a:srgbClr val="575756"/>
+                </a:solidFill>
+                <a:latin typeface="Verdana" pitchFamily="34" charset="0"/>
+                <a:ea typeface="Verdana" pitchFamily="34" charset="-122"/>
+                <a:cs typeface="Verdana" pitchFamily="34" charset="-120"/>
+              </a:rPr>
+              <a:t>Título de la diapositiva</a:t>
+            </a:r>
+            <a:endParaRPr lang="en-US" sz="4275" dirty="0"/>
+          </a:p>
+        </p:txBody>
+      </p:sp>
+      <p:sp>
+        <p:nvSpPr>
+          <p:cNvPr id="6" name="Shape 3"/>
+          <p:cNvSpPr/>
+          <p:nvPr/>
+        </p:nvSpPr>
+        <p:spPr>
+          <a:xfrm>
+            <a:off x="914400" y="2138809"/>
+            <a:ext cx="914400" cy="76200"/>
+          </a:xfrm>
+          <a:prstGeom prst="roundRect">
+            <a:avLst>
+              <a:gd name="adj" fmla="val 50000"/>
+            </a:avLst>
+          </a:prstGeom>
+          <a:solidFill>
+            <a:srgbClr val="5B2B82"/>
+          </a:solidFill>
+          <a:ln/>
+        </p:spPr>
+      </p:sp>
+      <p:sp>
+        <p:nvSpPr>
+          <p:cNvPr id="7" name="Shape 4"/>
+          <p:cNvSpPr/>
+          <p:nvPr/>
+        </p:nvSpPr>
+        <p:spPr>
+          <a:xfrm>
+            <a:off x="914400" y="2738884"/>
+            <a:ext cx="161925" cy="161925"/>
+          </a:xfrm>
+          <a:prstGeom prst="roundRect">
+            <a:avLst>
+              <a:gd name="adj" fmla="val 23529"/>
+            </a:avLst>
+          </a:prstGeom>
+          <a:solidFill>
+            <a:srgbClr val="12A095"/>
+          </a:solidFill>
+          <a:ln/>
+        </p:spPr>
+      </p:sp>
+      <p:sp>
+        <p:nvSpPr>
+          <p:cNvPr id="8" name="Text 5"/>
+          <p:cNvSpPr/>
+          <p:nvPr>
+            <p:ph type="body" idx="2"/>
+          </p:nvPr>
+        </p:nvSpPr>
+        <p:spPr>
+          <a:xfrm>
+            <a:off x="1280160" y="2642616"/>
+            <a:ext cx="16093440" cy="502920"/>
+          </a:xfrm>
+          <a:prstGeom prst="rect">
+            <a:avLst/>
+          </a:prstGeom>
+          <a:noFill/>
+          <a:ln/>
+        </p:spPr>
+        <p:txBody>
+          <a:bodyPr wrap="square" lIns="25400" tIns="25400" rIns="25400" bIns="25400" rtlCol="0" anchor="t">
+            <a:normAutofit/>
+          </a:bodyPr>
+          <a:lstStyle>
+            <a:lvl1pPr algn="l" indent="0" marL="0">
+              <a:lnSpc>
+                <a:spcPct val="100119"/>
+              </a:lnSpc>
+              <a:buNone/>
+              <a:defRPr sz="2175">
+                <a:solidFill>
+                  <a:srgbClr val="575756"/>
+                </a:solidFill>
+                <a:latin typeface="Source Sans 3" pitchFamily="34" charset="0"/>
+                <a:ea typeface="Source Sans 3" pitchFamily="34" charset="-122"/>
+                <a:cs typeface="Source Sans 3" pitchFamily="34" charset="-120"/>
+              </a:defRPr>
+            </a:lvl1pPr>
+          </a:lstStyle>
+          <a:p>
+            <a:pPr algn="l" indent="0" marL="0">
+              <a:lnSpc>
+                <a:spcPct val="100119"/>
+              </a:lnSpc>
+              <a:buNone/>
+            </a:pPr>
+            <a:r>
+              <a:rPr lang="en-US" sz="2175" dirty="0">
+                <a:solidFill>
+                  <a:srgbClr val="575756"/>
+                </a:solidFill>
+                <a:latin typeface="Source Sans 3" pitchFamily="34" charset="0"/>
+                <a:ea typeface="Source Sans 3" pitchFamily="34" charset="-122"/>
+                <a:cs typeface="Source Sans 3" pitchFamily="34" charset="-120"/>
+              </a:rPr>
+              <a:t>Primer punto clave de la diapositiva, con </a:t>
+            </a:r>
+            <a:pPr algn="l" indent="0" marL="0">
+              <a:lnSpc>
+                <a:spcPct val="100119"/>
+              </a:lnSpc>
+              <a:buNone/>
+            </a:pPr>
+            <a:r>
+              <a:rPr lang="en-US" sz="2175" b="1" dirty="0">
+                <a:solidFill>
+                  <a:srgbClr val="2C2C2B"/>
+                </a:solidFill>
+                <a:latin typeface="Source Sans 3" pitchFamily="34" charset="0"/>
+                <a:ea typeface="Source Sans 3" pitchFamily="34" charset="-122"/>
+                <a:cs typeface="Source Sans 3" pitchFamily="34" charset="-120"/>
+              </a:rPr>
+              <a:t>énfasis </a:t>
+            </a:r>
+            <a:pPr algn="l" indent="0" marL="0">
+              <a:lnSpc>
+                <a:spcPct val="100119"/>
+              </a:lnSpc>
+              <a:buNone/>
+            </a:pPr>
+            <a:r>
+              <a:rPr lang="en-US" sz="2175" dirty="0">
+                <a:solidFill>
+                  <a:srgbClr val="575756"/>
+                </a:solidFill>
+                <a:latin typeface="Source Sans 3" pitchFamily="34" charset="0"/>
+                <a:ea typeface="Source Sans 3" pitchFamily="34" charset="-122"/>
+                <a:cs typeface="Source Sans 3" pitchFamily="34" charset="-120"/>
+              </a:rPr>
+              <a:t>donde corresponda.</a:t>
+            </a:r>
+            <a:endParaRPr lang="en-US" sz="2175" dirty="0"/>
+          </a:p>
+        </p:txBody>
+      </p:sp>
+      <p:sp>
+        <p:nvSpPr>
+          <p:cNvPr id="9" name="Shape 6"/>
+          <p:cNvSpPr/>
+          <p:nvPr/>
+        </p:nvSpPr>
+        <p:spPr>
+          <a:xfrm>
+            <a:off x="914400" y="3396555"/>
+            <a:ext cx="161925" cy="161925"/>
+          </a:xfrm>
+          <a:prstGeom prst="roundRect">
+            <a:avLst>
+              <a:gd name="adj" fmla="val 23529"/>
+            </a:avLst>
+          </a:prstGeom>
+          <a:solidFill>
+            <a:srgbClr val="12A095"/>
+          </a:solidFill>
+          <a:ln/>
+        </p:spPr>
+      </p:sp>
+      <p:sp>
+        <p:nvSpPr>
+          <p:cNvPr id="10" name="Text 7"/>
+          <p:cNvSpPr/>
+          <p:nvPr>
+            <p:ph type="body" idx="3"/>
+          </p:nvPr>
+        </p:nvSpPr>
+        <p:spPr>
+          <a:xfrm>
+            <a:off x="1280160" y="3300984"/>
+            <a:ext cx="16093440" cy="502920"/>
+          </a:xfrm>
+          <a:prstGeom prst="rect">
+            <a:avLst/>
+          </a:prstGeom>
+          <a:noFill/>
+          <a:ln/>
+        </p:spPr>
+        <p:txBody>
+          <a:bodyPr wrap="square" lIns="25400" tIns="25400" rIns="25400" bIns="25400" rtlCol="0" anchor="t">
+            <a:normAutofit/>
+          </a:bodyPr>
+          <a:lstStyle>
+            <a:lvl1pPr algn="l" indent="0" marL="0">
+              <a:lnSpc>
+                <a:spcPct val="100119"/>
+              </a:lnSpc>
+              <a:buNone/>
+              <a:defRPr sz="2175">
+                <a:solidFill>
+                  <a:srgbClr val="575756"/>
+                </a:solidFill>
+                <a:latin typeface="Source Sans 3" pitchFamily="34" charset="0"/>
+                <a:ea typeface="Source Sans 3" pitchFamily="34" charset="-122"/>
+                <a:cs typeface="Source Sans 3" pitchFamily="34" charset="-120"/>
+              </a:defRPr>
+            </a:lvl1pPr>
+          </a:lstStyle>
+          <a:p>
+            <a:pPr algn="l" indent="0" marL="0">
+              <a:lnSpc>
+                <a:spcPct val="100119"/>
+              </a:lnSpc>
+              <a:buNone/>
+            </a:pPr>
+            <a:r>
+              <a:rPr lang="en-US" sz="2175" dirty="0">
+                <a:solidFill>
+                  <a:srgbClr val="575756"/>
+                </a:solidFill>
+                <a:latin typeface="Source Sans 3" pitchFamily="34" charset="0"/>
+                <a:ea typeface="Source Sans 3" pitchFamily="34" charset="-122"/>
+                <a:cs typeface="Source Sans 3" pitchFamily="34" charset="-120"/>
+              </a:rPr>
+              <a:t>Segundo punto clave, breve y directo.</a:t>
+            </a:r>
+            <a:endParaRPr lang="en-US" sz="2175" dirty="0"/>
+          </a:p>
+        </p:txBody>
+      </p:sp>
+      <p:sp>
+        <p:nvSpPr>
+          <p:cNvPr id="11" name="Shape 8"/>
+          <p:cNvSpPr/>
+          <p:nvPr/>
+        </p:nvSpPr>
+        <p:spPr>
+          <a:xfrm>
+            <a:off x="914400" y="4054227"/>
+            <a:ext cx="161925" cy="161925"/>
+          </a:xfrm>
+          <a:prstGeom prst="roundRect">
+            <a:avLst>
+              <a:gd name="adj" fmla="val 23529"/>
+            </a:avLst>
+          </a:prstGeom>
+          <a:solidFill>
+            <a:srgbClr val="12A095"/>
+          </a:solidFill>
+          <a:ln/>
+        </p:spPr>
+      </p:sp>
+      <p:sp>
+        <p:nvSpPr>
+          <p:cNvPr id="12" name="Text 9"/>
+          <p:cNvSpPr/>
+          <p:nvPr>
+            <p:ph type="body" idx="4"/>
+          </p:nvPr>
+        </p:nvSpPr>
+        <p:spPr>
+          <a:xfrm>
+            <a:off x="1280160" y="3959352"/>
+            <a:ext cx="16093440" cy="502920"/>
+          </a:xfrm>
+          <a:prstGeom prst="rect">
+            <a:avLst/>
+          </a:prstGeom>
+          <a:noFill/>
+          <a:ln/>
+        </p:spPr>
+        <p:txBody>
+          <a:bodyPr wrap="square" lIns="25400" tIns="25400" rIns="25400" bIns="25400" rtlCol="0" anchor="t">
+            <a:normAutofit/>
+          </a:bodyPr>
+          <a:lstStyle>
+            <a:lvl1pPr algn="l" indent="0" marL="0">
+              <a:lnSpc>
+                <a:spcPct val="100119"/>
+              </a:lnSpc>
+              <a:buNone/>
+              <a:defRPr sz="2175">
+                <a:solidFill>
+                  <a:srgbClr val="575756"/>
+                </a:solidFill>
+                <a:latin typeface="Source Sans 3" pitchFamily="34" charset="0"/>
+                <a:ea typeface="Source Sans 3" pitchFamily="34" charset="-122"/>
+                <a:cs typeface="Source Sans 3" pitchFamily="34" charset="-120"/>
+              </a:defRPr>
+            </a:lvl1pPr>
+          </a:lstStyle>
+          <a:p>
+            <a:pPr algn="l" indent="0" marL="0">
+              <a:lnSpc>
+                <a:spcPct val="100119"/>
+              </a:lnSpc>
+              <a:buNone/>
+            </a:pPr>
+            <a:r>
+              <a:rPr lang="en-US" sz="2175" dirty="0">
+                <a:solidFill>
+                  <a:srgbClr val="575756"/>
+                </a:solidFill>
+                <a:latin typeface="Source Sans 3" pitchFamily="34" charset="0"/>
+                <a:ea typeface="Source Sans 3" pitchFamily="34" charset="-122"/>
+                <a:cs typeface="Source Sans 3" pitchFamily="34" charset="-120"/>
+              </a:rPr>
+              <a:t>Tercer punto, con datos o contexto de respaldo.</a:t>
+            </a:r>
+            <a:endParaRPr lang="en-US" sz="2175" dirty="0"/>
+          </a:p>
+        </p:txBody>
+      </p:sp>
+      <p:sp>
+        <p:nvSpPr>
+          <p:cNvPr id="13" name="Shape 10"/>
+          <p:cNvSpPr/>
+          <p:nvPr/>
+        </p:nvSpPr>
+        <p:spPr>
+          <a:xfrm>
+            <a:off x="914400" y="4711898"/>
+            <a:ext cx="161925" cy="161925"/>
+          </a:xfrm>
+          <a:prstGeom prst="roundRect">
+            <a:avLst>
+              <a:gd name="adj" fmla="val 23529"/>
+            </a:avLst>
+          </a:prstGeom>
+          <a:solidFill>
+            <a:srgbClr val="12A095"/>
+          </a:solidFill>
+          <a:ln/>
+        </p:spPr>
+      </p:sp>
+      <p:sp>
+        <p:nvSpPr>
+          <p:cNvPr id="14" name="Text 11"/>
+          <p:cNvSpPr/>
+          <p:nvPr>
+            <p:ph type="body" idx="5"/>
+          </p:nvPr>
+        </p:nvSpPr>
+        <p:spPr>
+          <a:xfrm>
+            <a:off x="1280160" y="4617720"/>
+            <a:ext cx="16093440" cy="502920"/>
+          </a:xfrm>
+          <a:prstGeom prst="rect">
+            <a:avLst/>
+          </a:prstGeom>
+          <a:noFill/>
+          <a:ln/>
+        </p:spPr>
+        <p:txBody>
+          <a:bodyPr wrap="square" lIns="25400" tIns="25400" rIns="25400" bIns="25400" rtlCol="0" anchor="t">
+            <a:normAutofit/>
+          </a:bodyPr>
+          <a:lstStyle>
+            <a:lvl1pPr algn="l" indent="0" marL="0">
+              <a:lnSpc>
+                <a:spcPct val="100119"/>
+              </a:lnSpc>
+              <a:buNone/>
+              <a:defRPr sz="2175">
+                <a:solidFill>
+                  <a:srgbClr val="575756"/>
+                </a:solidFill>
+                <a:latin typeface="Source Sans 3" pitchFamily="34" charset="0"/>
+                <a:ea typeface="Source Sans 3" pitchFamily="34" charset="-122"/>
+                <a:cs typeface="Source Sans 3" pitchFamily="34" charset="-120"/>
+              </a:defRPr>
+            </a:lvl1pPr>
+          </a:lstStyle>
+          <a:p>
+            <a:pPr algn="l" indent="0" marL="0">
+              <a:lnSpc>
+                <a:spcPct val="100119"/>
+              </a:lnSpc>
+              <a:buNone/>
+            </a:pPr>
+            <a:r>
+              <a:rPr lang="en-US" sz="2175" dirty="0">
+                <a:solidFill>
+                  <a:srgbClr val="575756"/>
+                </a:solidFill>
+                <a:latin typeface="Source Sans 3" pitchFamily="34" charset="0"/>
+                <a:ea typeface="Source Sans 3" pitchFamily="34" charset="-122"/>
+                <a:cs typeface="Source Sans 3" pitchFamily="34" charset="-120"/>
+              </a:rPr>
+              <a:t>Cuarto punto, cierre o llamada a la acción.</a:t>
+            </a:r>
+            <a:endParaRPr lang="en-US" sz="2175" dirty="0"/>
+          </a:p>
+        </p:txBody>
+      </p:sp>
+      <p:sp>
+        <p:nvSpPr>
+          <p:cNvPr id="15" name="Shape 12"/>
+          <p:cNvSpPr/>
+          <p:nvPr/>
+        </p:nvSpPr>
+        <p:spPr>
+          <a:xfrm>
+            <a:off x="914400" y="9534525"/>
+            <a:ext cx="16459200" cy="9525"/>
+          </a:xfrm>
+          <a:prstGeom prst="rect">
+            <a:avLst/>
+          </a:prstGeom>
+          <a:solidFill>
+            <a:srgbClr val="D7D7D6"/>
+          </a:solidFill>
+          <a:ln/>
+        </p:spPr>
+      </p:sp>
+      <p:pic>
+        <p:nvPicPr>
+          <p:cNvPr id="16" name="Image 1" descr="preencoded.png">    </p:cNvPr>
+          <p:cNvPicPr>
+            <a:picLocks noChangeAspect="1"/>
+          </p:cNvPicPr>
+          <p:nvPr/>
+        </p:nvPicPr>
+        <p:blipFill>
+          <a:blip r:embed="rId2"/>
+          <a:stretch>
+            <a:fillRect/>
+          </a:stretch>
+        </p:blipFill>
+        <p:spPr>
+          <a:xfrm>
+            <a:off x="914400" y="9729788"/>
+            <a:ext cx="240804" cy="228600"/>
+          </a:xfrm>
+          <a:prstGeom prst="rect">
+            <a:avLst/>
+          </a:prstGeom>
+        </p:spPr>
+      </p:pic>
+      <p:sp>
+        <p:nvSpPr>
+          <p:cNvPr id="17" name="Text 13"/>
+          <p:cNvSpPr/>
+          <p:nvPr/>
+        </p:nvSpPr>
+        <p:spPr>
+          <a:xfrm>
+            <a:off x="1289304" y="9729216"/>
+            <a:ext cx="7315200" cy="274320"/>
+          </a:xfrm>
+          <a:prstGeom prst="rect">
+            <a:avLst/>
+          </a:prstGeom>
+          <a:noFill/>
+          <a:ln/>
+        </p:spPr>
+        <p:txBody>
+          <a:bodyPr wrap="square" lIns="0" tIns="0" rIns="0" bIns="0" rtlCol="0" anchor="t">
+            <a:normAutofit/>
+          </a:bodyPr>
+          <a:lstStyle/>
+          <a:p>
+            <a:pPr algn="l" indent="0" marL="0">
+              <a:lnSpc>
+                <a:spcPct val="108000"/>
+              </a:lnSpc>
+              <a:buNone/>
+            </a:pPr>
+            <a:r>
+              <a:rPr lang="en-US" sz="1350" dirty="0">
+                <a:solidFill>
+                  <a:srgbClr val="969695"/>
+                </a:solidFill>
+                <a:latin typeface="Source Sans 3" pitchFamily="34" charset="0"/>
+                <a:ea typeface="Source Sans 3" pitchFamily="34" charset="-122"/>
+                <a:cs typeface="Source Sans 3" pitchFamily="34" charset="-120"/>
+              </a:rPr>
+              <a:t>Comisión para el Mercado Financiero</a:t>
+            </a:r>
+            <a:endParaRPr lang="en-US" sz="1350" dirty="0"/>
+          </a:p>
+        </p:txBody>
+      </p:sp>
+      <p:sp>
+        <p:nvSpPr>
+          <p:cNvPr id="18" name="Text 14"/>
+          <p:cNvSpPr/>
+          <p:nvPr/>
+        </p:nvSpPr>
+        <p:spPr>
+          <a:xfrm>
+            <a:off x="11887200" y="9710928"/>
+            <a:ext cx="5486400" cy="292608"/>
+          </a:xfrm>
+          <a:prstGeom prst="rect">
+            <a:avLst/>
+          </a:prstGeom>
+          <a:noFill/>
+          <a:ln/>
+        </p:spPr>
+        <p:txBody>
+          <a:bodyPr wrap="square" lIns="25400" tIns="25400" rIns="25400" bIns="25400" rtlCol="0" anchor="t">
+            <a:normAutofit/>
+          </a:bodyPr>
+          <a:lstStyle/>
+          <a:p>
+            <a:pPr algn="r" indent="0" marL="0">
+              <a:lnSpc>
+                <a:spcPct val="108000"/>
+              </a:lnSpc>
+              <a:buNone/>
+            </a:pPr>
+            <a:r>
+              <a:rPr lang="en-US" sz="1350" dirty="0">
+                <a:solidFill>
+                  <a:srgbClr val="969695"/>
+                </a:solidFill>
+                <a:latin typeface="Source Sans 3" pitchFamily="34" charset="0"/>
+                <a:ea typeface="Source Sans 3" pitchFamily="34" charset="-122"/>
+                <a:cs typeface="Source Sans 3" pitchFamily="34" charset="-120"/>
+              </a:rPr>
+              <a:t>Marzo 2026 · </a:t>
+            </a:r>
+            <a:fld id="{B8527E0D-ED06-472B-B01F-2E0BAEC098E6}" type="slidenum">
+              <a:rPr lang="en-US" sz="1350" dirty="0">
+                <a:solidFill>
+                  <a:srgbClr val="969695"/>
+                </a:solidFill>
+                <a:latin typeface="Source Sans 3" pitchFamily="34" charset="0"/>
+                <a:ea typeface="Source Sans 3" pitchFamily="34" charset="-122"/>
+                <a:cs typeface="Source Sans 3" pitchFamily="34" charset="-120"/>
+              </a:rPr>
+              <a:t>3</a:t>
+            </a:fld>
+            <a:endParaRPr lang="en-US" sz="1350" dirty="0"/>
+          </a:p>
+        </p:txBody>
+      </p:sp>
+    </p:spTree>
+  </p:cSld>
+  <p:clrMapOvr>
+    <a:masterClrMapping/>
+  </p:clrMapOvr>
+</p:sldLayout>
+</file>
+
+<file path=ppt/slideLayouts/slideLayout5.xml><?xml version="1.0" encoding="utf-8"?>
+<p:sldLayout xmlns:p="http://schemas.openxmlformats.org/presentationml/2006/main" xmlns:a="http://schemas.openxmlformats.org/drawingml/2006/main" xmlns:r="http://schemas.openxmlformats.org/officeDocument/2006/relationships" preserve="1" type="blank">
+  <p:cSld name="CMF En blanco">
+    <p:bg>
+      <p:bgPr>
+        <a:solidFill>
+          <a:srgbClr val="FFFFFF"/>
+        </a:solidFill>
+      </p:bgPr>
+    </p:bg>
+    <p:spTree>
+      <p:nvGrpSpPr>
+        <p:cNvPr id="1" name=""/>
+        <p:cNvGrpSpPr/>
+        <p:nvPr/>
+      </p:nvGrpSpPr>
+      <p:grpSpPr>
+        <a:xfrm>
+          <a:off x="0" y="0"/>
+          <a:ext cx="0" cy="0"/>
+          <a:chOff x="0" y="0"/>
+          <a:chExt cx="0" cy="0"/>
+        </a:xfrm>
+      </p:grpSpPr>
+      <p:sp>
+        <p:nvSpPr>
+          <p:cNvPr id="2" name="Shape 0"/>
+          <p:cNvSpPr/>
+          <p:nvPr/>
+        </p:nvSpPr>
+        <p:spPr>
+          <a:xfrm>
+            <a:off x="0" y="0"/>
+            <a:ext cx="18288000" cy="114300"/>
+          </a:xfrm>
+          <a:prstGeom prst="rect">
+            <a:avLst/>
+          </a:prstGeom>
+          <a:solidFill>
+            <a:srgbClr val="5B2B82"/>
+          </a:solidFill>
+          <a:ln/>
+        </p:spPr>
+      </p:sp>
+      <p:pic>
+        <p:nvPicPr>
+          <p:cNvPr id="3" name="Image 0" descr="preencoded.png">    </p:cNvPr>
+          <p:cNvPicPr>
+            <a:picLocks noChangeAspect="1"/>
+          </p:cNvPicPr>
+          <p:nvPr/>
+        </p:nvPicPr>
+        <p:blipFill>
+          <a:blip r:embed="rId1"/>
+          <a:stretch>
+            <a:fillRect/>
+          </a:stretch>
+        </p:blipFill>
+        <p:spPr>
+          <a:xfrm>
+            <a:off x="15772656" y="542925"/>
+            <a:ext cx="1600944" cy="485775"/>
+          </a:xfrm>
+          <a:prstGeom prst="rect">
+            <a:avLst/>
+          </a:prstGeom>
+        </p:spPr>
+      </p:pic>
+      <p:sp>
+        <p:nvSpPr>
+          <p:cNvPr id="4" name="Shape 1"/>
+          <p:cNvSpPr/>
+          <p:nvPr/>
+        </p:nvSpPr>
+        <p:spPr>
+          <a:xfrm>
+            <a:off x="914400" y="9534525"/>
+            <a:ext cx="16459200" cy="9525"/>
+          </a:xfrm>
+          <a:prstGeom prst="rect">
+            <a:avLst/>
+          </a:prstGeom>
+          <a:solidFill>
+            <a:srgbClr val="D7D7D6"/>
+          </a:solidFill>
+          <a:ln/>
+        </p:spPr>
+      </p:sp>
+      <p:pic>
+        <p:nvPicPr>
+          <p:cNvPr id="5" name="Image 1" descr="preencoded.png">    </p:cNvPr>
+          <p:cNvPicPr>
+            <a:picLocks noChangeAspect="1"/>
+          </p:cNvPicPr>
+          <p:nvPr/>
+        </p:nvPicPr>
+        <p:blipFill>
+          <a:blip r:embed="rId2"/>
+          <a:stretch>
+            <a:fillRect/>
+          </a:stretch>
+        </p:blipFill>
+        <p:spPr>
+          <a:xfrm>
+            <a:off x="914400" y="9729788"/>
+            <a:ext cx="240804" cy="228600"/>
+          </a:xfrm>
+          <a:prstGeom prst="rect">
+            <a:avLst/>
+          </a:prstGeom>
+        </p:spPr>
+      </p:pic>
+      <p:sp>
+        <p:nvSpPr>
+          <p:cNvPr id="6" name="Text 2"/>
+          <p:cNvSpPr/>
+          <p:nvPr/>
+        </p:nvSpPr>
+        <p:spPr>
+          <a:xfrm>
+            <a:off x="1289304" y="9729216"/>
+            <a:ext cx="7315200" cy="274320"/>
+          </a:xfrm>
+          <a:prstGeom prst="rect">
+            <a:avLst/>
+          </a:prstGeom>
+          <a:noFill/>
+          <a:ln/>
+        </p:spPr>
+        <p:txBody>
+          <a:bodyPr wrap="square" lIns="0" tIns="0" rIns="0" bIns="0" rtlCol="0" anchor="t">
+            <a:normAutofit/>
+          </a:bodyPr>
+          <a:lstStyle/>
+          <a:p>
+            <a:pPr algn="l" indent="0" marL="0">
+              <a:lnSpc>
+                <a:spcPct val="108000"/>
+              </a:lnSpc>
+              <a:buNone/>
+            </a:pPr>
+            <a:r>
+              <a:rPr lang="en-US" sz="1350" dirty="0">
+                <a:solidFill>
+                  <a:srgbClr val="969695"/>
+                </a:solidFill>
+                <a:latin typeface="Source Sans 3" pitchFamily="34" charset="0"/>
+                <a:ea typeface="Source Sans 3" pitchFamily="34" charset="-122"/>
+                <a:cs typeface="Source Sans 3" pitchFamily="34" charset="-120"/>
+              </a:rPr>
+              <a:t>Comisión para el Mercado Financiero</a:t>
+            </a:r>
+            <a:endParaRPr lang="en-US" sz="1350" dirty="0"/>
+          </a:p>
+        </p:txBody>
+      </p:sp>
+      <p:sp>
+        <p:nvSpPr>
+          <p:cNvPr id="7" name="Text 3"/>
+          <p:cNvSpPr/>
+          <p:nvPr/>
+        </p:nvSpPr>
+        <p:spPr>
+          <a:xfrm>
+            <a:off x="11887200" y="9710928"/>
+            <a:ext cx="5486400" cy="292608"/>
+          </a:xfrm>
+          <a:prstGeom prst="rect">
+            <a:avLst/>
+          </a:prstGeom>
+          <a:noFill/>
+          <a:ln/>
+        </p:spPr>
+        <p:txBody>
+          <a:bodyPr wrap="square" lIns="25400" tIns="25400" rIns="25400" bIns="25400" rtlCol="0" anchor="t">
+            <a:normAutofit/>
+          </a:bodyPr>
+          <a:lstStyle/>
+          <a:p>
+            <a:pPr algn="r" indent="0" marL="0">
+              <a:lnSpc>
+                <a:spcPct val="108000"/>
+              </a:lnSpc>
+              <a:buNone/>
+            </a:pPr>
+            <a:r>
+              <a:rPr lang="en-US" sz="1350" dirty="0">
+                <a:solidFill>
+                  <a:srgbClr val="969695"/>
+                </a:solidFill>
+                <a:latin typeface="Source Sans 3" pitchFamily="34" charset="0"/>
+                <a:ea typeface="Source Sans 3" pitchFamily="34" charset="-122"/>
+                <a:cs typeface="Source Sans 3" pitchFamily="34" charset="-120"/>
+              </a:rPr>
+              <a:t>Marzo 2026 · </a:t>
+            </a:r>
+            <a:fld id="{98A198A5-C19F-473F-9A80-43D657BB568F}" type="slidenum">
+              <a:rPr lang="en-US" sz="1350" dirty="0">
+                <a:solidFill>
+                  <a:srgbClr val="969695"/>
+                </a:solidFill>
+                <a:latin typeface="Source Sans 3" pitchFamily="34" charset="0"/>
+                <a:ea typeface="Source Sans 3" pitchFamily="34" charset="-122"/>
+                <a:cs typeface="Source Sans 3" pitchFamily="34" charset="-120"/>
+              </a:rPr>
+              <a:t>2</a:t>
+            </a:fld>
+            <a:endParaRPr lang="en-US" sz="1350" dirty="0"/>
+          </a:p>
+        </p:txBody>
+      </p:sp>
+    </p:spTree>
+  </p:cSld>
+  <p:clrMapOvr>
+    <a:masterClrMapping/>
+  </p:clrMapOvr>
+</p:sldLayout>
+</file>
+
 <file path=ppt/slideMasters/slideMaster1.xml><?xml version="1.0" encoding="utf-8"?>
 <p:sldMaster xmlns:a="http://schemas.openxmlformats.org/drawingml/2006/main" xmlns:r="http://schemas.openxmlformats.org/officeDocument/2006/relationships" xmlns:p="http://schemas.openxmlformats.org/presentationml/2006/main">
   <p:cSld>
@@ -774,6 +2512,10 @@
   <p:clrMap bg1="lt1" tx1="dk1" bg2="lt2" tx2="dk2" accent1="accent1" accent2="accent2" accent3="accent3" accent4="accent4" accent5="accent5" accent6="accent6" hlink="hlink" folHlink="folHlink"/>
   <p:sldLayoutIdLst>
     <p:sldLayoutId id="2147483649" r:id="rId1"/>
+    <p:sldLayoutId id="2147483652" r:id="rIdL2"/>
+    <p:sldLayoutId id="2147483653" r:id="rIdL3"/>
+    <p:sldLayoutId id="2147483654" r:id="rIdL4"/>
+    <p:sldLayoutId id="2147483655" r:id="rIdL5"/>
   </p:sldLayoutIdLst>
   <p:hf sldNum="0" hdr="0" ftr="0" dt="0"/>
   <p:txStyles>
@@ -2486,4 +4228,299 @@
     </a:ext>
   </a:extLst>
 </a:theme>
+</file>
+
+<file path=ppt/theme/theme2.xml><?xml version="1.0" encoding="utf-8"?>
+<a:theme xmlns:a="http://schemas.openxmlformats.org/drawingml/2006/main" name="Office Theme Notas">
+  <a:themeElements>
+    <a:clrScheme name="Office">
+      <a:dk1>
+        <a:sysClr val="windowText" lastClr="000000"/>
+      </a:dk1>
+      <a:lt1>
+        <a:sysClr val="window" lastClr="FFFFFF"/>
+      </a:lt1>
+      <a:dk2>
+        <a:srgbClr val="44546A"/>
+      </a:dk2>
+      <a:lt2>
+        <a:srgbClr val="E7E6E6"/>
+      </a:lt2>
+      <a:accent1>
+        <a:srgbClr val="4472C4"/>
+      </a:accent1>
+      <a:accent2>
+        <a:srgbClr val="ED7D31"/>
+      </a:accent2>
+      <a:accent3>
+        <a:srgbClr val="A5A5A5"/>
+      </a:accent3>
+      <a:accent4>
+        <a:srgbClr val="FFC000"/>
+      </a:accent4>
+      <a:accent5>
+        <a:srgbClr val="5B9BD5"/>
+      </a:accent5>
+      <a:accent6>
+        <a:srgbClr val="70AD47"/>
+      </a:accent6>
+      <a:hlink>
+        <a:srgbClr val="0563C1"/>
+      </a:hlink>
+      <a:folHlink>
+        <a:srgbClr val="954F72"/>
+      </a:folHlink>
+    </a:clrScheme>
+    <a:fontScheme name="Office">
+      <a:majorFont>
+        <a:latin typeface="Calibri Light" panose="020F0302020204030204"/>
+        <a:ea typeface=""/>
+        <a:cs typeface=""/>
+        <a:font script="Jpan" typeface="游ゴシック Light"/>
+        <a:font script="Hang" typeface="맑은 고딕"/>
+        <a:font script="Hans" typeface="等线 Light"/>
+        <a:font script="Hant" typeface="新細明體"/>
+        <a:font script="Arab" typeface="Times New Roman"/>
+        <a:font script="Hebr" typeface="Times New Roman"/>
+        <a:font script="Thai" typeface="Angsana New"/>
+        <a:font script="Ethi" typeface="Nyala"/>
+        <a:font script="Beng" typeface="Vrinda"/>
+        <a:font script="Gujr" typeface="Shruti"/>
+        <a:font script="Khmr" typeface="MoolBoran"/>
+        <a:font script="Knda" typeface="Tunga"/>
+        <a:font script="Guru" typeface="Raavi"/>
+        <a:font script="Cans" typeface="Euphemia"/>
+        <a:font script="Cher" typeface="Plantagenet Cherokee"/>
+        <a:font script="Yiii" typeface="Microsoft Yi Baiti"/>
+        <a:font script="Tibt" typeface="Microsoft Himalaya"/>
+        <a:font script="Thaa" typeface="MV Boli"/>
+        <a:font script="Deva" typeface="Mangal"/>
+        <a:font script="Telu" typeface="Gautami"/>
+        <a:font script="Taml" typeface="Latha"/>
+        <a:font script="Syrc" typeface="Estrangelo Edessa"/>
+        <a:font script="Orya" typeface="Kalinga"/>
+        <a:font script="Mlym" typeface="Kartika"/>
+        <a:font script="Laoo" typeface="DokChampa"/>
+        <a:font script="Sinh" typeface="Iskoola Pota"/>
+        <a:font script="Mong" typeface="Mongolian Baiti"/>
+        <a:font script="Viet" typeface="Times New Roman"/>
+        <a:font script="Uigh" typeface="Microsoft Uighur"/>
+        <a:font script="Geor" typeface="Sylfaen"/>
+        <a:font script="Armn" typeface="Arial"/>
+        <a:font script="Bugi" typeface="Leelawadee UI"/>
+        <a:font script="Bopo" typeface="Microsoft JhengHei"/>
+        <a:font script="Java" typeface="Javanese Text"/>
+        <a:font script="Lisu" typeface="Segoe UI"/>
+        <a:font script="Mymr" typeface="Myanmar Text"/>
+        <a:font script="Nkoo" typeface="Ebrima"/>
+        <a:font script="Olck" typeface="Nirmala UI"/>
+        <a:font script="Osma" typeface="Ebrima"/>
+        <a:font script="Phag" typeface="Phagspa"/>
+        <a:font script="Syrn" typeface="Estrangelo Edessa"/>
+        <a:font script="Syrj" typeface="Estrangelo Edessa"/>
+        <a:font script="Syre" typeface="Estrangelo Edessa"/>
+        <a:font script="Sora" typeface="Nirmala UI"/>
+        <a:font script="Tale" typeface="Microsoft Tai Le"/>
+        <a:font script="Talu" typeface="Microsoft New Tai Lue"/>
+        <a:font script="Tfng" typeface="Ebrima"/>
+      </a:majorFont>
+      <a:minorFont>
+        <a:latin typeface="Calibri" panose="020F0502020204030204"/>
+        <a:ea typeface=""/>
+        <a:cs typeface=""/>
+        <a:font script="Jpan" typeface="游ゴシック"/>
+        <a:font script="Hang" typeface="맑은 고딕"/>
+        <a:font script="Hans" typeface="等线"/>
+        <a:font script="Hant" typeface="新細明體"/>
+        <a:font script="Arab" typeface="Arial"/>
+        <a:font script="Hebr" typeface="Arial"/>
+        <a:font script="Thai" typeface="Cordia New"/>
+        <a:font script="Ethi" typeface="Nyala"/>
+        <a:font script="Beng" typeface="Vrinda"/>
+        <a:font script="Gujr" typeface="Shruti"/>
+        <a:font script="Khmr" typeface="DaunPenh"/>
+        <a:font script="Knda" typeface="Tunga"/>
+        <a:font script="Guru" typeface="Raavi"/>
+        <a:font script="Cans" typeface="Euphemia"/>
+        <a:font script="Cher" typeface="Plantagenet Cherokee"/>
+        <a:font script="Yiii" typeface="Microsoft Yi Baiti"/>
+        <a:font script="Tibt" typeface="Microsoft Himalaya"/>
+        <a:font script="Thaa" typeface="MV Boli"/>
+        <a:font script="Deva" typeface="Mangal"/>
+        <a:font script="Telu" typeface="Gautami"/>
+        <a:font script="Taml" typeface="Latha"/>
+        <a:font script="Syrc" typeface="Estrangelo Edessa"/>
+        <a:font script="Orya" typeface="Kalinga"/>
+        <a:font script="Mlym" typeface="Kartika"/>
+        <a:font script="Laoo" typeface="DokChampa"/>
+        <a:font script="Sinh" typeface="Iskoola Pota"/>
+        <a:font script="Mong" typeface="Mongolian Baiti"/>
+        <a:font script="Viet" typeface="Arial"/>
+        <a:font script="Uigh" typeface="Microsoft Uighur"/>
+        <a:font script="Geor" typeface="Sylfaen"/>
+        <a:font script="Armn" typeface="Arial"/>
+        <a:font script="Bugi" typeface="Leelawadee UI"/>
+        <a:font script="Bopo" typeface="Microsoft JhengHei"/>
+        <a:font script="Java" typeface="Javanese Text"/>
+        <a:font script="Lisu" typeface="Segoe UI"/>
+        <a:font script="Mymr" typeface="Myanmar Text"/>
+        <a:font script="Nkoo" typeface="Ebrima"/>
+        <a:font script="Olck" typeface="Nirmala UI"/>
+        <a:font script="Osma" typeface="Ebrima"/>
+        <a:font script="Phag" typeface="Phagspa"/>
+        <a:font script="Syrn" typeface="Estrangelo Edessa"/>
+        <a:font script="Syrj" typeface="Estrangelo Edessa"/>
+        <a:font script="Syre" typeface="Estrangelo Edessa"/>
+        <a:font script="Sora" typeface="Nirmala UI"/>
+        <a:font script="Tale" typeface="Microsoft Tai Le"/>
+        <a:font script="Talu" typeface="Microsoft New Tai Lue"/>
+        <a:font script="Tfng" typeface="Ebrima"/>
+      </a:minorFont>
+    </a:fontScheme>
+    <a:fmtScheme name="Office">
+      <a:fillStyleLst>
+        <a:solidFill>
+          <a:schemeClr val="phClr"/>
+        </a:solidFill>
+        <a:gradFill rotWithShape="1">
+          <a:gsLst>
+            <a:gs pos="0">
+              <a:schemeClr val="phClr">
+                <a:lumMod val="110000"/>
+                <a:satMod val="105000"/>
+                <a:tint val="67000"/>
+              </a:schemeClr>
+            </a:gs>
+            <a:gs pos="50000">
+              <a:schemeClr val="phClr">
+                <a:lumMod val="105000"/>
+                <a:satMod val="103000"/>
+                <a:tint val="73000"/>
+              </a:schemeClr>
+            </a:gs>
+            <a:gs pos="100000">
+              <a:schemeClr val="phClr">
+                <a:lumMod val="105000"/>
+                <a:satMod val="109000"/>
+                <a:tint val="81000"/>
+              </a:schemeClr>
+            </a:gs>
+          </a:gsLst>
+          <a:lin ang="5400000" scaled="0"/>
+        </a:gradFill>
+        <a:gradFill rotWithShape="1">
+          <a:gsLst>
+            <a:gs pos="0">
+              <a:schemeClr val="phClr">
+                <a:satMod val="103000"/>
+                <a:lumMod val="102000"/>
+                <a:tint val="94000"/>
+              </a:schemeClr>
+            </a:gs>
+            <a:gs pos="50000">
+              <a:schemeClr val="phClr">
+                <a:satMod val="110000"/>
+                <a:lumMod val="100000"/>
+                <a:shade val="100000"/>
+              </a:schemeClr>
+            </a:gs>
+            <a:gs pos="100000">
+              <a:schemeClr val="phClr">
+                <a:lumMod val="99000"/>
+                <a:satMod val="120000"/>
+                <a:shade val="78000"/>
+              </a:schemeClr>
+            </a:gs>
+          </a:gsLst>
+          <a:lin ang="5400000" scaled="0"/>
+        </a:gradFill>
+      </a:fillStyleLst>
+      <a:lnStyleLst>
+        <a:ln w="6350" cap="flat" cmpd="sng" algn="ctr">
+          <a:solidFill>
+            <a:schemeClr val="phClr"/>
+          </a:solidFill>
+          <a:prstDash val="solid"/>
+          <a:miter lim="800000"/>
+        </a:ln>
+        <a:ln w="12700" cap="flat" cmpd="sng" algn="ctr">
+          <a:solidFill>
+            <a:schemeClr val="phClr"/>
+          </a:solidFill>
+          <a:prstDash val="solid"/>
+          <a:miter lim="800000"/>
+        </a:ln>
+        <a:ln w="19050" cap="flat" cmpd="sng" algn="ctr">
+          <a:solidFill>
+            <a:schemeClr val="phClr"/>
+          </a:solidFill>
+          <a:prstDash val="solid"/>
+          <a:miter lim="800000"/>
+        </a:ln>
+      </a:lnStyleLst>
+      <a:effectStyleLst>
+        <a:effectStyle>
+          <a:effectLst/>
+        </a:effectStyle>
+        <a:effectStyle>
+          <a:effectLst/>
+        </a:effectStyle>
+        <a:effectStyle>
+          <a:effectLst>
+            <a:outerShdw blurRad="57150" dist="19050" dir="5400000" algn="ctr" rotWithShape="0">
+              <a:srgbClr val="000000">
+                <a:alpha val="63000"/>
+              </a:srgbClr>
+            </a:outerShdw>
+          </a:effectLst>
+        </a:effectStyle>
+      </a:effectStyleLst>
+      <a:bgFillStyleLst>
+        <a:solidFill>
+          <a:schemeClr val="phClr"/>
+        </a:solidFill>
+        <a:solidFill>
+          <a:schemeClr val="phClr">
+            <a:tint val="95000"/>
+            <a:satMod val="170000"/>
+          </a:schemeClr>
+        </a:solidFill>
+        <a:gradFill rotWithShape="1">
+          <a:gsLst>
+            <a:gs pos="0">
+              <a:schemeClr val="phClr">
+                <a:tint val="93000"/>
+                <a:satMod val="150000"/>
+                <a:shade val="98000"/>
+                <a:lumMod val="102000"/>
+              </a:schemeClr>
+            </a:gs>
+            <a:gs pos="50000">
+              <a:schemeClr val="phClr">
+                <a:tint val="98000"/>
+                <a:satMod val="130000"/>
+                <a:shade val="90000"/>
+                <a:lumMod val="103000"/>
+              </a:schemeClr>
+            </a:gs>
+            <a:gs pos="100000">
+              <a:schemeClr val="phClr">
+                <a:shade val="63000"/>
+                <a:satMod val="120000"/>
+              </a:schemeClr>
+            </a:gs>
+          </a:gsLst>
+          <a:lin ang="5400000" scaled="0"/>
+        </a:gradFill>
+      </a:bgFillStyleLst>
+    </a:fmtScheme>
+  </a:themeElements>
+  <a:objectDefaults/>
+  <a:extraClrSchemeLst/>
+  <a:extLst>
+    <a:ext uri="{05A4C25C-085E-4340-85A3-A5531E510DB2}">
+      <thm15:themeFamily xmlns:thm15="http://schemas.microsoft.com/office/thememl/2012/main" name="Office Theme" id="{62F939B6-93AF-4DB8-9C6B-D6C7DFDC589F}" vid="{4A3C46E8-61CC-4603-A589-7422A47A8E4A}"/>
+    </a:ext>
+  </a:extLst>
+</a:theme>
 </file>
</xml_diff>

<commit_message>
Plantilla 2026 con diseños reutilizables y paquete corregido (#2)
Cuatro diseños con marcadores —Portada, Sección, Contenido y En blanco—
donde antes había un único DEFAULT vacío. El folio pasa a ser campo de
número de diapositiva. Se corrige el patrón de notas, que compartía tema
con el de diapositivas y hacía que PowerPoint pidiera reparar el archivo.

La gráfica no cambia y las imágenes se conservan byte a byte.
Detalle en guidelines/CMF-plantilla-2026.CAMBIOS.md
</commit_message>
<xml_diff>
--- a/guidelines/CMF-plantilla-2026.pptx
+++ b/guidelines/CMF-plantilla-2026.pptx
@@ -752,6 +752,1744 @@
 </p:sldLayout>
 </file>
 
+<file path=ppt/slideLayouts/slideLayout2.xml><?xml version="1.0" encoding="utf-8"?>
+<p:sldLayout xmlns:p="http://schemas.openxmlformats.org/presentationml/2006/main" xmlns:a="http://schemas.openxmlformats.org/drawingml/2006/main" xmlns:r="http://schemas.openxmlformats.org/officeDocument/2006/relationships" preserve="1" type="title">
+  <p:cSld name="CMF Portada">
+    <p:bg>
+      <p:bgPr>
+        <a:solidFill>
+          <a:srgbClr val="FFFFFF"/>
+        </a:solidFill>
+      </p:bgPr>
+    </p:bg>
+    <p:spTree>
+      <p:nvGrpSpPr>
+        <p:cNvPr id="1" name=""/>
+        <p:cNvGrpSpPr/>
+        <p:nvPr/>
+      </p:nvGrpSpPr>
+      <p:grpSpPr>
+        <a:xfrm>
+          <a:off x="0" y="0"/>
+          <a:ext cx="0" cy="0"/>
+          <a:chOff x="0" y="0"/>
+          <a:chExt cx="0" cy="0"/>
+        </a:xfrm>
+      </p:grpSpPr>
+      <p:sp>
+        <p:nvSpPr>
+          <p:cNvPr id="2" name="Shape 0"/>
+          <p:cNvSpPr/>
+          <p:nvPr/>
+        </p:nvSpPr>
+        <p:spPr>
+          <a:xfrm>
+            <a:off x="0" y="0"/>
+            <a:ext cx="18288000" cy="5600700"/>
+          </a:xfrm>
+          <a:prstGeom prst="rect">
+            <a:avLst/>
+          </a:prstGeom>
+          <a:solidFill>
+            <a:srgbClr val="162D56"/>
+          </a:solidFill>
+          <a:ln/>
+        </p:spPr>
+      </p:sp>
+      <p:pic>
+        <p:nvPicPr>
+          <p:cNvPr id="3" name="Image 0" descr="preencoded.png">    </p:cNvPr>
+          <p:cNvPicPr>
+            <a:picLocks noChangeAspect="1"/>
+          </p:cNvPicPr>
+          <p:nvPr/>
+        </p:nvPicPr>
+        <p:blipFill>
+          <a:blip r:embed="rId1"/>
+          <a:srcRect l="0" r="0" t="3330" b="3330"/>
+          <a:stretch/>
+        </p:blipFill>
+        <p:spPr>
+          <a:xfrm>
+            <a:off x="0" y="0"/>
+            <a:ext cx="18288000" cy="5600700"/>
+          </a:xfrm>
+          <a:prstGeom prst="rect">
+            <a:avLst/>
+          </a:prstGeom>
+        </p:spPr>
+      </p:pic>
+      <p:sp>
+        <p:nvSpPr>
+          <p:cNvPr id="4" name="Text 1"/>
+          <p:cNvSpPr/>
+          <p:nvPr>
+            <p:ph type="ctrTitle"/>
+          </p:nvPr>
+        </p:nvSpPr>
+        <p:spPr>
+          <a:xfrm>
+            <a:off x="1828800" y="5971032"/>
+            <a:ext cx="14630400" cy="1280160"/>
+          </a:xfrm>
+          <a:prstGeom prst="rect">
+            <a:avLst/>
+          </a:prstGeom>
+          <a:noFill/>
+          <a:ln/>
+        </p:spPr>
+        <p:txBody>
+          <a:bodyPr wrap="square" lIns="25400" tIns="25400" rIns="25400" bIns="25400" rtlCol="0" anchor="t">
+            <a:normAutofit/>
+          </a:bodyPr>
+          <a:lstStyle>
+            <a:lvl1pPr algn="ctr" indent="0" marL="0">
+              <a:lnSpc>
+                <a:spcPct val="98630"/>
+              </a:lnSpc>
+              <a:buNone/>
+              <a:defRPr sz="4500" b="1">
+                <a:solidFill>
+                  <a:srgbClr val="575756"/>
+                </a:solidFill>
+                <a:latin typeface="Verdana" pitchFamily="34" charset="0"/>
+                <a:ea typeface="Verdana" pitchFamily="34" charset="-122"/>
+                <a:cs typeface="Verdana" pitchFamily="34" charset="-120"/>
+              </a:defRPr>
+            </a:lvl1pPr>
+          </a:lstStyle>
+          <a:p>
+            <a:pPr algn="ctr" indent="0" marL="0">
+              <a:lnSpc>
+                <a:spcPct val="98630"/>
+              </a:lnSpc>
+              <a:buNone/>
+            </a:pPr>
+            <a:r>
+              <a:rPr lang="en-US" sz="4500" b="1" spc="-45" kern="0" dirty="0">
+                <a:solidFill>
+                  <a:srgbClr val="575756"/>
+                </a:solidFill>
+                <a:latin typeface="Verdana" pitchFamily="34" charset="0"/>
+                <a:ea typeface="Verdana" pitchFamily="34" charset="-122"/>
+                <a:cs typeface="Verdana" pitchFamily="34" charset="-120"/>
+              </a:rPr>
+              <a:t>Título de la presentación</a:t>
+            </a:r>
+            <a:endParaRPr lang="en-US" sz="4500" dirty="0"/>
+          </a:p>
+        </p:txBody>
+      </p:sp>
+      <p:sp>
+        <p:nvSpPr>
+          <p:cNvPr id="5" name="Text 2"/>
+          <p:cNvSpPr/>
+          <p:nvPr>
+            <p:ph type="subTitle" idx="1"/>
+          </p:nvPr>
+        </p:nvSpPr>
+        <p:spPr>
+          <a:xfrm>
+            <a:off x="1828800" y="7424928"/>
+            <a:ext cx="14630400" cy="512064"/>
+          </a:xfrm>
+          <a:prstGeom prst="rect">
+            <a:avLst/>
+          </a:prstGeom>
+          <a:noFill/>
+          <a:ln/>
+        </p:spPr>
+        <p:txBody>
+          <a:bodyPr wrap="square" lIns="25400" tIns="25400" rIns="25400" bIns="25400" rtlCol="0" anchor="t">
+            <a:normAutofit/>
+          </a:bodyPr>
+          <a:lstStyle>
+            <a:lvl1pPr algn="ctr" indent="0" marL="0">
+              <a:lnSpc>
+                <a:spcPct val="123750"/>
+              </a:lnSpc>
+              <a:buNone/>
+              <a:defRPr sz="2475" b="1">
+                <a:solidFill>
+                  <a:srgbClr val="2C2C2B"/>
+                </a:solidFill>
+                <a:latin typeface="Verdana" pitchFamily="34" charset="0"/>
+                <a:ea typeface="Verdana" pitchFamily="34" charset="-122"/>
+                <a:cs typeface="Verdana" pitchFamily="34" charset="-120"/>
+              </a:defRPr>
+            </a:lvl1pPr>
+          </a:lstStyle>
+          <a:p>
+            <a:pPr algn="ctr" indent="0" marL="0">
+              <a:lnSpc>
+                <a:spcPct val="123750"/>
+              </a:lnSpc>
+              <a:buNone/>
+            </a:pPr>
+            <a:r>
+              <a:rPr lang="en-US" sz="2475" b="1" dirty="0">
+                <a:solidFill>
+                  <a:srgbClr val="2C2C2B"/>
+                </a:solidFill>
+                <a:latin typeface="Verdana" pitchFamily="34" charset="0"/>
+                <a:ea typeface="Verdana" pitchFamily="34" charset="-122"/>
+                <a:cs typeface="Verdana" pitchFamily="34" charset="-120"/>
+              </a:rPr>
+              <a:t>Nombre Apellido</a:t>
+            </a:r>
+            <a:endParaRPr lang="en-US" sz="2475" dirty="0"/>
+          </a:p>
+        </p:txBody>
+      </p:sp>
+      <p:sp>
+        <p:nvSpPr>
+          <p:cNvPr id="6" name="Text 3"/>
+          <p:cNvSpPr/>
+          <p:nvPr>
+            <p:ph type="body" idx="2"/>
+          </p:nvPr>
+        </p:nvSpPr>
+        <p:spPr>
+          <a:xfrm>
+            <a:off x="1828800" y="7955280"/>
+            <a:ext cx="14630400" cy="621792"/>
+          </a:xfrm>
+          <a:prstGeom prst="rect">
+            <a:avLst/>
+          </a:prstGeom>
+          <a:noFill/>
+          <a:ln/>
+        </p:spPr>
+        <p:txBody>
+          <a:bodyPr wrap="square" lIns="25400" tIns="25400" rIns="25400" bIns="25400" rtlCol="0" anchor="t">
+            <a:normAutofit/>
+          </a:bodyPr>
+          <a:lstStyle>
+            <a:lvl1pPr algn="ctr" indent="0" marL="0">
+              <a:lnSpc>
+                <a:spcPct val="121800"/>
+              </a:lnSpc>
+              <a:buNone/>
+              <a:defRPr sz="1575">
+                <a:solidFill>
+                  <a:srgbClr val="575756"/>
+                </a:solidFill>
+                <a:latin typeface="Verdana" pitchFamily="34" charset="0"/>
+                <a:ea typeface="Verdana" pitchFamily="34" charset="-122"/>
+                <a:cs typeface="Verdana" pitchFamily="34" charset="-120"/>
+              </a:defRPr>
+            </a:lvl1pPr>
+          </a:lstStyle>
+          <a:p>
+            <a:pPr algn="ctr" indent="0" marL="0">
+              <a:lnSpc>
+                <a:spcPct val="121800"/>
+              </a:lnSpc>
+              <a:buNone/>
+            </a:pPr>
+            <a:r>
+              <a:rPr lang="en-US" sz="1575" dirty="0">
+                <a:solidFill>
+                  <a:srgbClr val="575756"/>
+                </a:solidFill>
+                <a:latin typeface="Verdana" pitchFamily="34" charset="0"/>
+                <a:ea typeface="Verdana" pitchFamily="34" charset="-122"/>
+                <a:cs typeface="Verdana" pitchFamily="34" charset="-120"/>
+              </a:rPr>
+              <a:t>Cargo / Dirección Comisión para el Mercado Financiero</a:t>
+            </a:r>
+            <a:endParaRPr lang="en-US" sz="1575" dirty="0"/>
+          </a:p>
+        </p:txBody>
+      </p:sp>
+      <p:sp>
+        <p:nvSpPr>
+          <p:cNvPr id="7" name="Text 4"/>
+          <p:cNvSpPr/>
+          <p:nvPr>
+            <p:ph type="body" idx="3"/>
+          </p:nvPr>
+        </p:nvSpPr>
+        <p:spPr>
+          <a:xfrm>
+            <a:off x="1828800" y="8933688"/>
+            <a:ext cx="14630400" cy="365760"/>
+          </a:xfrm>
+          <a:prstGeom prst="rect">
+            <a:avLst/>
+          </a:prstGeom>
+          <a:noFill/>
+          <a:ln/>
+        </p:spPr>
+        <p:txBody>
+          <a:bodyPr wrap="square" lIns="25400" tIns="25400" rIns="25400" bIns="25400" rtlCol="0" anchor="t">
+            <a:normAutofit/>
+          </a:bodyPr>
+          <a:lstStyle>
+            <a:lvl1pPr algn="ctr" indent="0" marL="0">
+              <a:lnSpc>
+                <a:spcPct val="123214"/>
+              </a:lnSpc>
+              <a:buNone/>
+              <a:defRPr sz="1725" b="1">
+                <a:solidFill>
+                  <a:srgbClr val="575756"/>
+                </a:solidFill>
+                <a:latin typeface="Verdana" pitchFamily="34" charset="0"/>
+                <a:ea typeface="Verdana" pitchFamily="34" charset="-122"/>
+                <a:cs typeface="Verdana" pitchFamily="34" charset="-120"/>
+              </a:defRPr>
+            </a:lvl1pPr>
+          </a:lstStyle>
+          <a:p>
+            <a:pPr algn="ctr" indent="0" marL="0">
+              <a:lnSpc>
+                <a:spcPct val="123214"/>
+              </a:lnSpc>
+              <a:buNone/>
+            </a:pPr>
+            <a:r>
+              <a:rPr lang="en-US" sz="1725" b="1" dirty="0">
+                <a:solidFill>
+                  <a:srgbClr val="575756"/>
+                </a:solidFill>
+                <a:latin typeface="Verdana" pitchFamily="34" charset="0"/>
+                <a:ea typeface="Verdana" pitchFamily="34" charset="-122"/>
+                <a:cs typeface="Verdana" pitchFamily="34" charset="-120"/>
+              </a:rPr>
+              <a:t>Marzo 2026</a:t>
+            </a:r>
+            <a:endParaRPr lang="en-US" sz="1725" dirty="0"/>
+          </a:p>
+        </p:txBody>
+      </p:sp>
+      <p:sp>
+        <p:nvSpPr>
+          <p:cNvPr id="8" name="Shape 5"/>
+          <p:cNvSpPr/>
+          <p:nvPr/>
+        </p:nvSpPr>
+        <p:spPr>
+          <a:xfrm>
+            <a:off x="0" y="9629775"/>
+            <a:ext cx="18288000" cy="657225"/>
+          </a:xfrm>
+          <a:prstGeom prst="rect">
+            <a:avLst/>
+          </a:prstGeom>
+          <a:solidFill>
+            <a:srgbClr val="112351"/>
+          </a:solidFill>
+          <a:ln/>
+        </p:spPr>
+      </p:sp>
+      <p:pic>
+        <p:nvPicPr>
+          <p:cNvPr id="9" name="Image 1" descr="preencoded.png">    </p:cNvPr>
+          <p:cNvPicPr>
+            <a:picLocks noChangeAspect="1"/>
+          </p:cNvPicPr>
+          <p:nvPr/>
+        </p:nvPicPr>
+        <p:blipFill>
+          <a:blip r:embed="rId2"/>
+          <a:srcRect l="0" r="0" t="11564" b="11564"/>
+          <a:stretch/>
+        </p:blipFill>
+        <p:spPr>
+          <a:xfrm>
+            <a:off x="0" y="9629775"/>
+            <a:ext cx="18288000" cy="657225"/>
+          </a:xfrm>
+          <a:prstGeom prst="rect">
+            <a:avLst/>
+          </a:prstGeom>
+        </p:spPr>
+      </p:pic>
+      <p:sp>
+        <p:nvSpPr>
+          <p:cNvPr id="10" name="Text 6"/>
+          <p:cNvSpPr/>
+          <p:nvPr>
+            <p:ph type="sldNum" idx="10"/>
+          </p:nvPr>
+        </p:nvSpPr>
+        <p:spPr>
+          <a:xfrm>
+            <a:off x="16002000" y="9848088"/>
+            <a:ext cx="1371600" cy="265176"/>
+          </a:xfrm>
+          <a:prstGeom prst="rect">
+            <a:avLst/>
+          </a:prstGeom>
+          <a:noFill/>
+          <a:ln/>
+        </p:spPr>
+        <p:txBody>
+          <a:bodyPr wrap="square" lIns="25400" tIns="25400" rIns="25400" bIns="25400" rtlCol="0" anchor="t">
+            <a:normAutofit/>
+          </a:bodyPr>
+          <a:lstStyle>
+            <a:lvl1pPr algn="r" indent="0" marL="0">
+              <a:lnSpc>
+                <a:spcPct val="109091"/>
+              </a:lnSpc>
+              <a:buNone/>
+              <a:defRPr sz="1200">
+                <a:solidFill>
+                  <a:srgbClr val="FFFFFF">
+                    <a:alpha val="85000"/>
+                  </a:srgbClr>
+                </a:solidFill>
+                <a:latin typeface="Source Sans 3" pitchFamily="34" charset="0"/>
+                <a:ea typeface="Source Sans 3" pitchFamily="34" charset="-122"/>
+                <a:cs typeface="Source Sans 3" pitchFamily="34" charset="-120"/>
+              </a:defRPr>
+            </a:lvl1pPr>
+          </a:lstStyle>
+          <a:p>
+            <a:pPr algn="r" indent="0" marL="0">
+              <a:lnSpc>
+                <a:spcPct val="109091"/>
+              </a:lnSpc>
+              <a:buNone/>
+            </a:pPr>
+            <a:fld id="{B5E4E44B-B729-4933-9576-2397FE414F70}" type="slidenum">
+              <a:rPr lang="en-US" sz="1200" dirty="0">
+                <a:solidFill>
+                  <a:srgbClr val="FFFFFF">
+                    <a:alpha val="85000"/>
+                  </a:srgbClr>
+                </a:solidFill>
+                <a:latin typeface="Source Sans 3" pitchFamily="34" charset="0"/>
+                <a:ea typeface="Source Sans 3" pitchFamily="34" charset="-122"/>
+                <a:cs typeface="Source Sans 3" pitchFamily="34" charset="-120"/>
+              </a:rPr>
+              <a:t>1</a:t>
+            </a:fld>
+            <a:endParaRPr lang="en-US" sz="1200" dirty="0"/>
+          </a:p>
+        </p:txBody>
+      </p:sp>
+    </p:spTree>
+  </p:cSld>
+  <p:clrMapOvr>
+    <a:masterClrMapping/>
+  </p:clrMapOvr>
+</p:sldLayout>
+</file>
+
+<file path=ppt/slideLayouts/slideLayout3.xml><?xml version="1.0" encoding="utf-8"?>
+<p:sldLayout xmlns:p="http://schemas.openxmlformats.org/presentationml/2006/main" xmlns:a="http://schemas.openxmlformats.org/drawingml/2006/main" xmlns:r="http://schemas.openxmlformats.org/officeDocument/2006/relationships" preserve="1" type="secHead">
+  <p:cSld name="CMF Sección">
+    <p:bg>
+      <p:bgPr>
+        <a:solidFill>
+          <a:srgbClr val="FFFFFF"/>
+        </a:solidFill>
+      </p:bgPr>
+    </p:bg>
+    <p:spTree>
+      <p:nvGrpSpPr>
+        <p:cNvPr id="1" name=""/>
+        <p:cNvGrpSpPr/>
+        <p:nvPr/>
+      </p:nvGrpSpPr>
+      <p:grpSpPr>
+        <a:xfrm>
+          <a:off x="0" y="0"/>
+          <a:ext cx="0" cy="0"/>
+          <a:chOff x="0" y="0"/>
+          <a:chExt cx="0" cy="0"/>
+        </a:xfrm>
+      </p:grpSpPr>
+      <p:sp>
+        <p:nvSpPr>
+          <p:cNvPr id="2" name="Shape 0"/>
+          <p:cNvSpPr/>
+          <p:nvPr/>
+        </p:nvSpPr>
+        <p:spPr>
+          <a:xfrm>
+            <a:off x="0" y="0"/>
+            <a:ext cx="18288000" cy="114300"/>
+          </a:xfrm>
+          <a:prstGeom prst="rect">
+            <a:avLst/>
+          </a:prstGeom>
+          <a:solidFill>
+            <a:srgbClr val="5B2B82"/>
+          </a:solidFill>
+          <a:ln/>
+        </p:spPr>
+      </p:sp>
+      <p:sp>
+        <p:nvSpPr>
+          <p:cNvPr id="3" name="Text 1"/>
+          <p:cNvSpPr/>
+          <p:nvPr>
+            <p:ph type="body" idx="1"/>
+          </p:nvPr>
+        </p:nvSpPr>
+        <p:spPr>
+          <a:xfrm>
+            <a:off x="914400" y="640080"/>
+            <a:ext cx="16459200" cy="338328"/>
+          </a:xfrm>
+          <a:prstGeom prst="rect">
+            <a:avLst/>
+          </a:prstGeom>
+          <a:noFill/>
+          <a:ln/>
+        </p:spPr>
+        <p:txBody>
+          <a:bodyPr wrap="square" lIns="25400" tIns="25400" rIns="25400" bIns="25400" rtlCol="0" anchor="t">
+            <a:normAutofit/>
+          </a:bodyPr>
+          <a:lstStyle>
+            <a:lvl1pPr algn="l" indent="0" marL="0">
+              <a:lnSpc>
+                <a:spcPct val="105000"/>
+              </a:lnSpc>
+              <a:buNone/>
+              <a:defRPr sz="1575" b="1">
+                <a:solidFill>
+                  <a:srgbClr val="8547AD"/>
+                </a:solidFill>
+                <a:latin typeface="Source Sans 3" pitchFamily="34" charset="0"/>
+                <a:ea typeface="Source Sans 3" pitchFamily="34" charset="-122"/>
+                <a:cs typeface="Source Sans 3" pitchFamily="34" charset="-120"/>
+              </a:defRPr>
+            </a:lvl1pPr>
+          </a:lstStyle>
+          <a:p>
+            <a:pPr algn="l" indent="0" marL="0">
+              <a:lnSpc>
+                <a:spcPct val="105000"/>
+              </a:lnSpc>
+              <a:buNone/>
+            </a:pPr>
+            <a:r>
+              <a:rPr lang="en-US" sz="1575" b="1" spc="126" kern="0" dirty="0">
+                <a:solidFill>
+                  <a:srgbClr val="8547AD"/>
+                </a:solidFill>
+                <a:latin typeface="Source Sans 3" pitchFamily="34" charset="0"/>
+                <a:ea typeface="Source Sans 3" pitchFamily="34" charset="-122"/>
+                <a:cs typeface="Source Sans 3" pitchFamily="34" charset="-120"/>
+              </a:rPr>
+              <a:t>ANTETÍTULO DE SECCIÓN</a:t>
+            </a:r>
+            <a:endParaRPr lang="en-US" sz="1575" dirty="0"/>
+          </a:p>
+        </p:txBody>
+      </p:sp>
+      <p:pic>
+        <p:nvPicPr>
+          <p:cNvPr id="4" name="Image 0" descr="preencoded.png">    </p:cNvPr>
+          <p:cNvPicPr>
+            <a:picLocks noChangeAspect="1"/>
+          </p:cNvPicPr>
+          <p:nvPr/>
+        </p:nvPicPr>
+        <p:blipFill>
+          <a:blip r:embed="rId1"/>
+          <a:stretch>
+            <a:fillRect/>
+          </a:stretch>
+        </p:blipFill>
+        <p:spPr>
+          <a:xfrm>
+            <a:off x="15772656" y="542925"/>
+            <a:ext cx="1600944" cy="485775"/>
+          </a:xfrm>
+          <a:prstGeom prst="rect">
+            <a:avLst/>
+          </a:prstGeom>
+        </p:spPr>
+      </p:pic>
+      <p:sp>
+        <p:nvSpPr>
+          <p:cNvPr id="5" name="Text 2"/>
+          <p:cNvSpPr/>
+          <p:nvPr>
+            <p:ph type="title"/>
+          </p:nvPr>
+        </p:nvSpPr>
+        <p:spPr>
+          <a:xfrm>
+            <a:off x="914400" y="1197864"/>
+            <a:ext cx="16459200" cy="822960"/>
+          </a:xfrm>
+          <a:prstGeom prst="rect">
+            <a:avLst/>
+          </a:prstGeom>
+          <a:noFill/>
+          <a:ln/>
+        </p:spPr>
+        <p:txBody>
+          <a:bodyPr wrap="square" lIns="25400" tIns="25400" rIns="25400" bIns="25400" rtlCol="0" anchor="t">
+            <a:normAutofit/>
+          </a:bodyPr>
+          <a:lstStyle>
+            <a:lvl1pPr algn="l" indent="0" marL="0">
+              <a:lnSpc>
+                <a:spcPct val="95000"/>
+              </a:lnSpc>
+              <a:buNone/>
+              <a:defRPr sz="4275" b="1">
+                <a:solidFill>
+                  <a:srgbClr val="575756"/>
+                </a:solidFill>
+                <a:latin typeface="Verdana" pitchFamily="34" charset="0"/>
+                <a:ea typeface="Verdana" pitchFamily="34" charset="-122"/>
+                <a:cs typeface="Verdana" pitchFamily="34" charset="-120"/>
+              </a:defRPr>
+            </a:lvl1pPr>
+          </a:lstStyle>
+          <a:p>
+            <a:pPr algn="l" indent="0" marL="0">
+              <a:lnSpc>
+                <a:spcPct val="95000"/>
+              </a:lnSpc>
+              <a:buNone/>
+            </a:pPr>
+            <a:r>
+              <a:rPr lang="en-US" sz="4275" b="1" spc="-43" kern="0" dirty="0">
+                <a:solidFill>
+                  <a:srgbClr val="575756"/>
+                </a:solidFill>
+                <a:latin typeface="Verdana" pitchFamily="34" charset="0"/>
+                <a:ea typeface="Verdana" pitchFamily="34" charset="-122"/>
+                <a:cs typeface="Verdana" pitchFamily="34" charset="-120"/>
+              </a:rPr>
+              <a:t>Título de la diapositiva</a:t>
+            </a:r>
+            <a:endParaRPr lang="en-US" sz="4275" dirty="0"/>
+          </a:p>
+        </p:txBody>
+      </p:sp>
+      <p:sp>
+        <p:nvSpPr>
+          <p:cNvPr id="6" name="Shape 3"/>
+          <p:cNvSpPr/>
+          <p:nvPr/>
+        </p:nvSpPr>
+        <p:spPr>
+          <a:xfrm>
+            <a:off x="914400" y="2138809"/>
+            <a:ext cx="914400" cy="76200"/>
+          </a:xfrm>
+          <a:prstGeom prst="roundRect">
+            <a:avLst>
+              <a:gd name="adj" fmla="val 50000"/>
+            </a:avLst>
+          </a:prstGeom>
+          <a:solidFill>
+            <a:srgbClr val="5B2B82"/>
+          </a:solidFill>
+          <a:ln/>
+        </p:spPr>
+      </p:sp>
+      <p:sp>
+        <p:nvSpPr>
+          <p:cNvPr id="15" name="Shape 12"/>
+          <p:cNvSpPr/>
+          <p:nvPr/>
+        </p:nvSpPr>
+        <p:spPr>
+          <a:xfrm>
+            <a:off x="914400" y="9534525"/>
+            <a:ext cx="16459200" cy="9525"/>
+          </a:xfrm>
+          <a:prstGeom prst="rect">
+            <a:avLst/>
+          </a:prstGeom>
+          <a:solidFill>
+            <a:srgbClr val="D7D7D6"/>
+          </a:solidFill>
+          <a:ln/>
+        </p:spPr>
+      </p:sp>
+      <p:pic>
+        <p:nvPicPr>
+          <p:cNvPr id="16" name="Image 1" descr="preencoded.png">    </p:cNvPr>
+          <p:cNvPicPr>
+            <a:picLocks noChangeAspect="1"/>
+          </p:cNvPicPr>
+          <p:nvPr/>
+        </p:nvPicPr>
+        <p:blipFill>
+          <a:blip r:embed="rId2"/>
+          <a:stretch>
+            <a:fillRect/>
+          </a:stretch>
+        </p:blipFill>
+        <p:spPr>
+          <a:xfrm>
+            <a:off x="914400" y="9729788"/>
+            <a:ext cx="240804" cy="228600"/>
+          </a:xfrm>
+          <a:prstGeom prst="rect">
+            <a:avLst/>
+          </a:prstGeom>
+        </p:spPr>
+      </p:pic>
+      <p:sp>
+        <p:nvSpPr>
+          <p:cNvPr id="17" name="Text 13"/>
+          <p:cNvSpPr/>
+          <p:nvPr/>
+        </p:nvSpPr>
+        <p:spPr>
+          <a:xfrm>
+            <a:off x="1289304" y="9729216"/>
+            <a:ext cx="7315200" cy="274320"/>
+          </a:xfrm>
+          <a:prstGeom prst="rect">
+            <a:avLst/>
+          </a:prstGeom>
+          <a:noFill/>
+          <a:ln/>
+        </p:spPr>
+        <p:txBody>
+          <a:bodyPr wrap="square" lIns="0" tIns="0" rIns="0" bIns="0" rtlCol="0" anchor="t">
+            <a:normAutofit/>
+          </a:bodyPr>
+          <a:lstStyle/>
+          <a:p>
+            <a:pPr algn="l" indent="0" marL="0">
+              <a:lnSpc>
+                <a:spcPct val="108000"/>
+              </a:lnSpc>
+              <a:buNone/>
+            </a:pPr>
+            <a:r>
+              <a:rPr lang="en-US" sz="1350" dirty="0">
+                <a:solidFill>
+                  <a:srgbClr val="969695"/>
+                </a:solidFill>
+                <a:latin typeface="Source Sans 3" pitchFamily="34" charset="0"/>
+                <a:ea typeface="Source Sans 3" pitchFamily="34" charset="-122"/>
+                <a:cs typeface="Source Sans 3" pitchFamily="34" charset="-120"/>
+              </a:rPr>
+              <a:t>Comisión para el Mercado Financiero</a:t>
+            </a:r>
+            <a:endParaRPr lang="en-US" sz="1350" dirty="0"/>
+          </a:p>
+        </p:txBody>
+      </p:sp>
+      <p:sp>
+        <p:nvSpPr>
+          <p:cNvPr id="18" name="Text 14"/>
+          <p:cNvSpPr/>
+          <p:nvPr/>
+        </p:nvSpPr>
+        <p:spPr>
+          <a:xfrm>
+            <a:off x="11887200" y="9710928"/>
+            <a:ext cx="5486400" cy="292608"/>
+          </a:xfrm>
+          <a:prstGeom prst="rect">
+            <a:avLst/>
+          </a:prstGeom>
+          <a:noFill/>
+          <a:ln/>
+        </p:spPr>
+        <p:txBody>
+          <a:bodyPr wrap="square" lIns="25400" tIns="25400" rIns="25400" bIns="25400" rtlCol="0" anchor="t">
+            <a:normAutofit/>
+          </a:bodyPr>
+          <a:lstStyle/>
+          <a:p>
+            <a:pPr algn="r" indent="0" marL="0">
+              <a:lnSpc>
+                <a:spcPct val="108000"/>
+              </a:lnSpc>
+              <a:buNone/>
+            </a:pPr>
+            <a:r>
+              <a:rPr lang="en-US" sz="1350" dirty="0">
+                <a:solidFill>
+                  <a:srgbClr val="969695"/>
+                </a:solidFill>
+                <a:latin typeface="Source Sans 3" pitchFamily="34" charset="0"/>
+                <a:ea typeface="Source Sans 3" pitchFamily="34" charset="-122"/>
+                <a:cs typeface="Source Sans 3" pitchFamily="34" charset="-120"/>
+              </a:rPr>
+              <a:t>Marzo 2026 · </a:t>
+            </a:r>
+            <a:fld id="{296237B6-5E3F-4A53-8617-0B6476DA17E1}" type="slidenum">
+              <a:rPr lang="en-US" sz="1350" dirty="0">
+                <a:solidFill>
+                  <a:srgbClr val="969695"/>
+                </a:solidFill>
+                <a:latin typeface="Source Sans 3" pitchFamily="34" charset="0"/>
+                <a:ea typeface="Source Sans 3" pitchFamily="34" charset="-122"/>
+                <a:cs typeface="Source Sans 3" pitchFamily="34" charset="-120"/>
+              </a:rPr>
+              <a:t>3</a:t>
+            </a:fld>
+            <a:endParaRPr lang="en-US" sz="1350" dirty="0"/>
+          </a:p>
+        </p:txBody>
+      </p:sp>
+    </p:spTree>
+  </p:cSld>
+  <p:clrMapOvr>
+    <a:masterClrMapping/>
+  </p:clrMapOvr>
+</p:sldLayout>
+</file>
+
+<file path=ppt/slideLayouts/slideLayout4.xml><?xml version="1.0" encoding="utf-8"?>
+<p:sldLayout xmlns:p="http://schemas.openxmlformats.org/presentationml/2006/main" xmlns:a="http://schemas.openxmlformats.org/drawingml/2006/main" xmlns:r="http://schemas.openxmlformats.org/officeDocument/2006/relationships" preserve="1" type="obj">
+  <p:cSld name="CMF Contenido">
+    <p:bg>
+      <p:bgPr>
+        <a:solidFill>
+          <a:srgbClr val="FFFFFF"/>
+        </a:solidFill>
+      </p:bgPr>
+    </p:bg>
+    <p:spTree>
+      <p:nvGrpSpPr>
+        <p:cNvPr id="1" name=""/>
+        <p:cNvGrpSpPr/>
+        <p:nvPr/>
+      </p:nvGrpSpPr>
+      <p:grpSpPr>
+        <a:xfrm>
+          <a:off x="0" y="0"/>
+          <a:ext cx="0" cy="0"/>
+          <a:chOff x="0" y="0"/>
+          <a:chExt cx="0" cy="0"/>
+        </a:xfrm>
+      </p:grpSpPr>
+      <p:sp>
+        <p:nvSpPr>
+          <p:cNvPr id="2" name="Shape 0"/>
+          <p:cNvSpPr/>
+          <p:nvPr/>
+        </p:nvSpPr>
+        <p:spPr>
+          <a:xfrm>
+            <a:off x="0" y="0"/>
+            <a:ext cx="18288000" cy="114300"/>
+          </a:xfrm>
+          <a:prstGeom prst="rect">
+            <a:avLst/>
+          </a:prstGeom>
+          <a:solidFill>
+            <a:srgbClr val="5B2B82"/>
+          </a:solidFill>
+          <a:ln/>
+        </p:spPr>
+      </p:sp>
+      <p:sp>
+        <p:nvSpPr>
+          <p:cNvPr id="3" name="Text 1"/>
+          <p:cNvSpPr/>
+          <p:nvPr>
+            <p:ph type="body" idx="1"/>
+          </p:nvPr>
+        </p:nvSpPr>
+        <p:spPr>
+          <a:xfrm>
+            <a:off x="914400" y="640080"/>
+            <a:ext cx="16459200" cy="338328"/>
+          </a:xfrm>
+          <a:prstGeom prst="rect">
+            <a:avLst/>
+          </a:prstGeom>
+          <a:noFill/>
+          <a:ln/>
+        </p:spPr>
+        <p:txBody>
+          <a:bodyPr wrap="square" lIns="25400" tIns="25400" rIns="25400" bIns="25400" rtlCol="0" anchor="t">
+            <a:normAutofit/>
+          </a:bodyPr>
+          <a:lstStyle>
+            <a:lvl1pPr algn="l" indent="0" marL="0">
+              <a:lnSpc>
+                <a:spcPct val="105000"/>
+              </a:lnSpc>
+              <a:buNone/>
+              <a:defRPr sz="1575" b="1">
+                <a:solidFill>
+                  <a:srgbClr val="8547AD"/>
+                </a:solidFill>
+                <a:latin typeface="Source Sans 3" pitchFamily="34" charset="0"/>
+                <a:ea typeface="Source Sans 3" pitchFamily="34" charset="-122"/>
+                <a:cs typeface="Source Sans 3" pitchFamily="34" charset="-120"/>
+              </a:defRPr>
+            </a:lvl1pPr>
+          </a:lstStyle>
+          <a:p>
+            <a:pPr algn="l" indent="0" marL="0">
+              <a:lnSpc>
+                <a:spcPct val="105000"/>
+              </a:lnSpc>
+              <a:buNone/>
+            </a:pPr>
+            <a:r>
+              <a:rPr lang="en-US" sz="1575" b="1" spc="126" kern="0" dirty="0">
+                <a:solidFill>
+                  <a:srgbClr val="8547AD"/>
+                </a:solidFill>
+                <a:latin typeface="Source Sans 3" pitchFamily="34" charset="0"/>
+                <a:ea typeface="Source Sans 3" pitchFamily="34" charset="-122"/>
+                <a:cs typeface="Source Sans 3" pitchFamily="34" charset="-120"/>
+              </a:rPr>
+              <a:t>ANTETÍTULO DE SECCIÓN</a:t>
+            </a:r>
+            <a:endParaRPr lang="en-US" sz="1575" dirty="0"/>
+          </a:p>
+        </p:txBody>
+      </p:sp>
+      <p:pic>
+        <p:nvPicPr>
+          <p:cNvPr id="4" name="Image 0" descr="preencoded.png">    </p:cNvPr>
+          <p:cNvPicPr>
+            <a:picLocks noChangeAspect="1"/>
+          </p:cNvPicPr>
+          <p:nvPr/>
+        </p:nvPicPr>
+        <p:blipFill>
+          <a:blip r:embed="rId1"/>
+          <a:stretch>
+            <a:fillRect/>
+          </a:stretch>
+        </p:blipFill>
+        <p:spPr>
+          <a:xfrm>
+            <a:off x="15772656" y="542925"/>
+            <a:ext cx="1600944" cy="485775"/>
+          </a:xfrm>
+          <a:prstGeom prst="rect">
+            <a:avLst/>
+          </a:prstGeom>
+        </p:spPr>
+      </p:pic>
+      <p:sp>
+        <p:nvSpPr>
+          <p:cNvPr id="5" name="Text 2"/>
+          <p:cNvSpPr/>
+          <p:nvPr>
+            <p:ph type="title"/>
+          </p:nvPr>
+        </p:nvSpPr>
+        <p:spPr>
+          <a:xfrm>
+            <a:off x="914400" y="1197864"/>
+            <a:ext cx="16459200" cy="822960"/>
+          </a:xfrm>
+          <a:prstGeom prst="rect">
+            <a:avLst/>
+          </a:prstGeom>
+          <a:noFill/>
+          <a:ln/>
+        </p:spPr>
+        <p:txBody>
+          <a:bodyPr wrap="square" lIns="25400" tIns="25400" rIns="25400" bIns="25400" rtlCol="0" anchor="t">
+            <a:normAutofit/>
+          </a:bodyPr>
+          <a:lstStyle>
+            <a:lvl1pPr algn="l" indent="0" marL="0">
+              <a:lnSpc>
+                <a:spcPct val="95000"/>
+              </a:lnSpc>
+              <a:buNone/>
+              <a:defRPr sz="4275" b="1">
+                <a:solidFill>
+                  <a:srgbClr val="575756"/>
+                </a:solidFill>
+                <a:latin typeface="Verdana" pitchFamily="34" charset="0"/>
+                <a:ea typeface="Verdana" pitchFamily="34" charset="-122"/>
+                <a:cs typeface="Verdana" pitchFamily="34" charset="-120"/>
+              </a:defRPr>
+            </a:lvl1pPr>
+          </a:lstStyle>
+          <a:p>
+            <a:pPr algn="l" indent="0" marL="0">
+              <a:lnSpc>
+                <a:spcPct val="95000"/>
+              </a:lnSpc>
+              <a:buNone/>
+            </a:pPr>
+            <a:r>
+              <a:rPr lang="en-US" sz="4275" b="1" spc="-43" kern="0" dirty="0">
+                <a:solidFill>
+                  <a:srgbClr val="575756"/>
+                </a:solidFill>
+                <a:latin typeface="Verdana" pitchFamily="34" charset="0"/>
+                <a:ea typeface="Verdana" pitchFamily="34" charset="-122"/>
+                <a:cs typeface="Verdana" pitchFamily="34" charset="-120"/>
+              </a:rPr>
+              <a:t>Título de la diapositiva</a:t>
+            </a:r>
+            <a:endParaRPr lang="en-US" sz="4275" dirty="0"/>
+          </a:p>
+        </p:txBody>
+      </p:sp>
+      <p:sp>
+        <p:nvSpPr>
+          <p:cNvPr id="6" name="Shape 3"/>
+          <p:cNvSpPr/>
+          <p:nvPr/>
+        </p:nvSpPr>
+        <p:spPr>
+          <a:xfrm>
+            <a:off x="914400" y="2138809"/>
+            <a:ext cx="914400" cy="76200"/>
+          </a:xfrm>
+          <a:prstGeom prst="roundRect">
+            <a:avLst>
+              <a:gd name="adj" fmla="val 50000"/>
+            </a:avLst>
+          </a:prstGeom>
+          <a:solidFill>
+            <a:srgbClr val="5B2B82"/>
+          </a:solidFill>
+          <a:ln/>
+        </p:spPr>
+      </p:sp>
+      <p:sp>
+        <p:nvSpPr>
+          <p:cNvPr id="7" name="Shape 4"/>
+          <p:cNvSpPr/>
+          <p:nvPr/>
+        </p:nvSpPr>
+        <p:spPr>
+          <a:xfrm>
+            <a:off x="914400" y="2738884"/>
+            <a:ext cx="161925" cy="161925"/>
+          </a:xfrm>
+          <a:prstGeom prst="roundRect">
+            <a:avLst>
+              <a:gd name="adj" fmla="val 23529"/>
+            </a:avLst>
+          </a:prstGeom>
+          <a:solidFill>
+            <a:srgbClr val="12A095"/>
+          </a:solidFill>
+          <a:ln/>
+        </p:spPr>
+      </p:sp>
+      <p:sp>
+        <p:nvSpPr>
+          <p:cNvPr id="8" name="Text 5"/>
+          <p:cNvSpPr/>
+          <p:nvPr>
+            <p:ph type="body" idx="2"/>
+          </p:nvPr>
+        </p:nvSpPr>
+        <p:spPr>
+          <a:xfrm>
+            <a:off x="1280160" y="2642616"/>
+            <a:ext cx="16093440" cy="502920"/>
+          </a:xfrm>
+          <a:prstGeom prst="rect">
+            <a:avLst/>
+          </a:prstGeom>
+          <a:noFill/>
+          <a:ln/>
+        </p:spPr>
+        <p:txBody>
+          <a:bodyPr wrap="square" lIns="25400" tIns="25400" rIns="25400" bIns="25400" rtlCol="0" anchor="t">
+            <a:normAutofit/>
+          </a:bodyPr>
+          <a:lstStyle>
+            <a:lvl1pPr algn="l" indent="0" marL="0">
+              <a:lnSpc>
+                <a:spcPct val="100119"/>
+              </a:lnSpc>
+              <a:buNone/>
+              <a:defRPr sz="2175">
+                <a:solidFill>
+                  <a:srgbClr val="575756"/>
+                </a:solidFill>
+                <a:latin typeface="Source Sans 3" pitchFamily="34" charset="0"/>
+                <a:ea typeface="Source Sans 3" pitchFamily="34" charset="-122"/>
+                <a:cs typeface="Source Sans 3" pitchFamily="34" charset="-120"/>
+              </a:defRPr>
+            </a:lvl1pPr>
+          </a:lstStyle>
+          <a:p>
+            <a:pPr algn="l" indent="0" marL="0">
+              <a:lnSpc>
+                <a:spcPct val="100119"/>
+              </a:lnSpc>
+              <a:buNone/>
+            </a:pPr>
+            <a:r>
+              <a:rPr lang="en-US" sz="2175" dirty="0">
+                <a:solidFill>
+                  <a:srgbClr val="575756"/>
+                </a:solidFill>
+                <a:latin typeface="Source Sans 3" pitchFamily="34" charset="0"/>
+                <a:ea typeface="Source Sans 3" pitchFamily="34" charset="-122"/>
+                <a:cs typeface="Source Sans 3" pitchFamily="34" charset="-120"/>
+              </a:rPr>
+              <a:t>Primer punto clave de la diapositiva, con </a:t>
+            </a:r>
+            <a:pPr algn="l" indent="0" marL="0">
+              <a:lnSpc>
+                <a:spcPct val="100119"/>
+              </a:lnSpc>
+              <a:buNone/>
+            </a:pPr>
+            <a:r>
+              <a:rPr lang="en-US" sz="2175" b="1" dirty="0">
+                <a:solidFill>
+                  <a:srgbClr val="2C2C2B"/>
+                </a:solidFill>
+                <a:latin typeface="Source Sans 3" pitchFamily="34" charset="0"/>
+                <a:ea typeface="Source Sans 3" pitchFamily="34" charset="-122"/>
+                <a:cs typeface="Source Sans 3" pitchFamily="34" charset="-120"/>
+              </a:rPr>
+              <a:t>énfasis </a:t>
+            </a:r>
+            <a:pPr algn="l" indent="0" marL="0">
+              <a:lnSpc>
+                <a:spcPct val="100119"/>
+              </a:lnSpc>
+              <a:buNone/>
+            </a:pPr>
+            <a:r>
+              <a:rPr lang="en-US" sz="2175" dirty="0">
+                <a:solidFill>
+                  <a:srgbClr val="575756"/>
+                </a:solidFill>
+                <a:latin typeface="Source Sans 3" pitchFamily="34" charset="0"/>
+                <a:ea typeface="Source Sans 3" pitchFamily="34" charset="-122"/>
+                <a:cs typeface="Source Sans 3" pitchFamily="34" charset="-120"/>
+              </a:rPr>
+              <a:t>donde corresponda.</a:t>
+            </a:r>
+            <a:endParaRPr lang="en-US" sz="2175" dirty="0"/>
+          </a:p>
+        </p:txBody>
+      </p:sp>
+      <p:sp>
+        <p:nvSpPr>
+          <p:cNvPr id="9" name="Shape 6"/>
+          <p:cNvSpPr/>
+          <p:nvPr/>
+        </p:nvSpPr>
+        <p:spPr>
+          <a:xfrm>
+            <a:off x="914400" y="3396555"/>
+            <a:ext cx="161925" cy="161925"/>
+          </a:xfrm>
+          <a:prstGeom prst="roundRect">
+            <a:avLst>
+              <a:gd name="adj" fmla="val 23529"/>
+            </a:avLst>
+          </a:prstGeom>
+          <a:solidFill>
+            <a:srgbClr val="12A095"/>
+          </a:solidFill>
+          <a:ln/>
+        </p:spPr>
+      </p:sp>
+      <p:sp>
+        <p:nvSpPr>
+          <p:cNvPr id="10" name="Text 7"/>
+          <p:cNvSpPr/>
+          <p:nvPr>
+            <p:ph type="body" idx="3"/>
+          </p:nvPr>
+        </p:nvSpPr>
+        <p:spPr>
+          <a:xfrm>
+            <a:off x="1280160" y="3300984"/>
+            <a:ext cx="16093440" cy="502920"/>
+          </a:xfrm>
+          <a:prstGeom prst="rect">
+            <a:avLst/>
+          </a:prstGeom>
+          <a:noFill/>
+          <a:ln/>
+        </p:spPr>
+        <p:txBody>
+          <a:bodyPr wrap="square" lIns="25400" tIns="25400" rIns="25400" bIns="25400" rtlCol="0" anchor="t">
+            <a:normAutofit/>
+          </a:bodyPr>
+          <a:lstStyle>
+            <a:lvl1pPr algn="l" indent="0" marL="0">
+              <a:lnSpc>
+                <a:spcPct val="100119"/>
+              </a:lnSpc>
+              <a:buNone/>
+              <a:defRPr sz="2175">
+                <a:solidFill>
+                  <a:srgbClr val="575756"/>
+                </a:solidFill>
+                <a:latin typeface="Source Sans 3" pitchFamily="34" charset="0"/>
+                <a:ea typeface="Source Sans 3" pitchFamily="34" charset="-122"/>
+                <a:cs typeface="Source Sans 3" pitchFamily="34" charset="-120"/>
+              </a:defRPr>
+            </a:lvl1pPr>
+          </a:lstStyle>
+          <a:p>
+            <a:pPr algn="l" indent="0" marL="0">
+              <a:lnSpc>
+                <a:spcPct val="100119"/>
+              </a:lnSpc>
+              <a:buNone/>
+            </a:pPr>
+            <a:r>
+              <a:rPr lang="en-US" sz="2175" dirty="0">
+                <a:solidFill>
+                  <a:srgbClr val="575756"/>
+                </a:solidFill>
+                <a:latin typeface="Source Sans 3" pitchFamily="34" charset="0"/>
+                <a:ea typeface="Source Sans 3" pitchFamily="34" charset="-122"/>
+                <a:cs typeface="Source Sans 3" pitchFamily="34" charset="-120"/>
+              </a:rPr>
+              <a:t>Segundo punto clave, breve y directo.</a:t>
+            </a:r>
+            <a:endParaRPr lang="en-US" sz="2175" dirty="0"/>
+          </a:p>
+        </p:txBody>
+      </p:sp>
+      <p:sp>
+        <p:nvSpPr>
+          <p:cNvPr id="11" name="Shape 8"/>
+          <p:cNvSpPr/>
+          <p:nvPr/>
+        </p:nvSpPr>
+        <p:spPr>
+          <a:xfrm>
+            <a:off x="914400" y="4054227"/>
+            <a:ext cx="161925" cy="161925"/>
+          </a:xfrm>
+          <a:prstGeom prst="roundRect">
+            <a:avLst>
+              <a:gd name="adj" fmla="val 23529"/>
+            </a:avLst>
+          </a:prstGeom>
+          <a:solidFill>
+            <a:srgbClr val="12A095"/>
+          </a:solidFill>
+          <a:ln/>
+        </p:spPr>
+      </p:sp>
+      <p:sp>
+        <p:nvSpPr>
+          <p:cNvPr id="12" name="Text 9"/>
+          <p:cNvSpPr/>
+          <p:nvPr>
+            <p:ph type="body" idx="4"/>
+          </p:nvPr>
+        </p:nvSpPr>
+        <p:spPr>
+          <a:xfrm>
+            <a:off x="1280160" y="3959352"/>
+            <a:ext cx="16093440" cy="502920"/>
+          </a:xfrm>
+          <a:prstGeom prst="rect">
+            <a:avLst/>
+          </a:prstGeom>
+          <a:noFill/>
+          <a:ln/>
+        </p:spPr>
+        <p:txBody>
+          <a:bodyPr wrap="square" lIns="25400" tIns="25400" rIns="25400" bIns="25400" rtlCol="0" anchor="t">
+            <a:normAutofit/>
+          </a:bodyPr>
+          <a:lstStyle>
+            <a:lvl1pPr algn="l" indent="0" marL="0">
+              <a:lnSpc>
+                <a:spcPct val="100119"/>
+              </a:lnSpc>
+              <a:buNone/>
+              <a:defRPr sz="2175">
+                <a:solidFill>
+                  <a:srgbClr val="575756"/>
+                </a:solidFill>
+                <a:latin typeface="Source Sans 3" pitchFamily="34" charset="0"/>
+                <a:ea typeface="Source Sans 3" pitchFamily="34" charset="-122"/>
+                <a:cs typeface="Source Sans 3" pitchFamily="34" charset="-120"/>
+              </a:defRPr>
+            </a:lvl1pPr>
+          </a:lstStyle>
+          <a:p>
+            <a:pPr algn="l" indent="0" marL="0">
+              <a:lnSpc>
+                <a:spcPct val="100119"/>
+              </a:lnSpc>
+              <a:buNone/>
+            </a:pPr>
+            <a:r>
+              <a:rPr lang="en-US" sz="2175" dirty="0">
+                <a:solidFill>
+                  <a:srgbClr val="575756"/>
+                </a:solidFill>
+                <a:latin typeface="Source Sans 3" pitchFamily="34" charset="0"/>
+                <a:ea typeface="Source Sans 3" pitchFamily="34" charset="-122"/>
+                <a:cs typeface="Source Sans 3" pitchFamily="34" charset="-120"/>
+              </a:rPr>
+              <a:t>Tercer punto, con datos o contexto de respaldo.</a:t>
+            </a:r>
+            <a:endParaRPr lang="en-US" sz="2175" dirty="0"/>
+          </a:p>
+        </p:txBody>
+      </p:sp>
+      <p:sp>
+        <p:nvSpPr>
+          <p:cNvPr id="13" name="Shape 10"/>
+          <p:cNvSpPr/>
+          <p:nvPr/>
+        </p:nvSpPr>
+        <p:spPr>
+          <a:xfrm>
+            <a:off x="914400" y="4711898"/>
+            <a:ext cx="161925" cy="161925"/>
+          </a:xfrm>
+          <a:prstGeom prst="roundRect">
+            <a:avLst>
+              <a:gd name="adj" fmla="val 23529"/>
+            </a:avLst>
+          </a:prstGeom>
+          <a:solidFill>
+            <a:srgbClr val="12A095"/>
+          </a:solidFill>
+          <a:ln/>
+        </p:spPr>
+      </p:sp>
+      <p:sp>
+        <p:nvSpPr>
+          <p:cNvPr id="14" name="Text 11"/>
+          <p:cNvSpPr/>
+          <p:nvPr>
+            <p:ph type="body" idx="5"/>
+          </p:nvPr>
+        </p:nvSpPr>
+        <p:spPr>
+          <a:xfrm>
+            <a:off x="1280160" y="4617720"/>
+            <a:ext cx="16093440" cy="502920"/>
+          </a:xfrm>
+          <a:prstGeom prst="rect">
+            <a:avLst/>
+          </a:prstGeom>
+          <a:noFill/>
+          <a:ln/>
+        </p:spPr>
+        <p:txBody>
+          <a:bodyPr wrap="square" lIns="25400" tIns="25400" rIns="25400" bIns="25400" rtlCol="0" anchor="t">
+            <a:normAutofit/>
+          </a:bodyPr>
+          <a:lstStyle>
+            <a:lvl1pPr algn="l" indent="0" marL="0">
+              <a:lnSpc>
+                <a:spcPct val="100119"/>
+              </a:lnSpc>
+              <a:buNone/>
+              <a:defRPr sz="2175">
+                <a:solidFill>
+                  <a:srgbClr val="575756"/>
+                </a:solidFill>
+                <a:latin typeface="Source Sans 3" pitchFamily="34" charset="0"/>
+                <a:ea typeface="Source Sans 3" pitchFamily="34" charset="-122"/>
+                <a:cs typeface="Source Sans 3" pitchFamily="34" charset="-120"/>
+              </a:defRPr>
+            </a:lvl1pPr>
+          </a:lstStyle>
+          <a:p>
+            <a:pPr algn="l" indent="0" marL="0">
+              <a:lnSpc>
+                <a:spcPct val="100119"/>
+              </a:lnSpc>
+              <a:buNone/>
+            </a:pPr>
+            <a:r>
+              <a:rPr lang="en-US" sz="2175" dirty="0">
+                <a:solidFill>
+                  <a:srgbClr val="575756"/>
+                </a:solidFill>
+                <a:latin typeface="Source Sans 3" pitchFamily="34" charset="0"/>
+                <a:ea typeface="Source Sans 3" pitchFamily="34" charset="-122"/>
+                <a:cs typeface="Source Sans 3" pitchFamily="34" charset="-120"/>
+              </a:rPr>
+              <a:t>Cuarto punto, cierre o llamada a la acción.</a:t>
+            </a:r>
+            <a:endParaRPr lang="en-US" sz="2175" dirty="0"/>
+          </a:p>
+        </p:txBody>
+      </p:sp>
+      <p:sp>
+        <p:nvSpPr>
+          <p:cNvPr id="15" name="Shape 12"/>
+          <p:cNvSpPr/>
+          <p:nvPr/>
+        </p:nvSpPr>
+        <p:spPr>
+          <a:xfrm>
+            <a:off x="914400" y="9534525"/>
+            <a:ext cx="16459200" cy="9525"/>
+          </a:xfrm>
+          <a:prstGeom prst="rect">
+            <a:avLst/>
+          </a:prstGeom>
+          <a:solidFill>
+            <a:srgbClr val="D7D7D6"/>
+          </a:solidFill>
+          <a:ln/>
+        </p:spPr>
+      </p:sp>
+      <p:pic>
+        <p:nvPicPr>
+          <p:cNvPr id="16" name="Image 1" descr="preencoded.png">    </p:cNvPr>
+          <p:cNvPicPr>
+            <a:picLocks noChangeAspect="1"/>
+          </p:cNvPicPr>
+          <p:nvPr/>
+        </p:nvPicPr>
+        <p:blipFill>
+          <a:blip r:embed="rId2"/>
+          <a:stretch>
+            <a:fillRect/>
+          </a:stretch>
+        </p:blipFill>
+        <p:spPr>
+          <a:xfrm>
+            <a:off x="914400" y="9729788"/>
+            <a:ext cx="240804" cy="228600"/>
+          </a:xfrm>
+          <a:prstGeom prst="rect">
+            <a:avLst/>
+          </a:prstGeom>
+        </p:spPr>
+      </p:pic>
+      <p:sp>
+        <p:nvSpPr>
+          <p:cNvPr id="17" name="Text 13"/>
+          <p:cNvSpPr/>
+          <p:nvPr/>
+        </p:nvSpPr>
+        <p:spPr>
+          <a:xfrm>
+            <a:off x="1289304" y="9729216"/>
+            <a:ext cx="7315200" cy="274320"/>
+          </a:xfrm>
+          <a:prstGeom prst="rect">
+            <a:avLst/>
+          </a:prstGeom>
+          <a:noFill/>
+          <a:ln/>
+        </p:spPr>
+        <p:txBody>
+          <a:bodyPr wrap="square" lIns="0" tIns="0" rIns="0" bIns="0" rtlCol="0" anchor="t">
+            <a:normAutofit/>
+          </a:bodyPr>
+          <a:lstStyle/>
+          <a:p>
+            <a:pPr algn="l" indent="0" marL="0">
+              <a:lnSpc>
+                <a:spcPct val="108000"/>
+              </a:lnSpc>
+              <a:buNone/>
+            </a:pPr>
+            <a:r>
+              <a:rPr lang="en-US" sz="1350" dirty="0">
+                <a:solidFill>
+                  <a:srgbClr val="969695"/>
+                </a:solidFill>
+                <a:latin typeface="Source Sans 3" pitchFamily="34" charset="0"/>
+                <a:ea typeface="Source Sans 3" pitchFamily="34" charset="-122"/>
+                <a:cs typeface="Source Sans 3" pitchFamily="34" charset="-120"/>
+              </a:rPr>
+              <a:t>Comisión para el Mercado Financiero</a:t>
+            </a:r>
+            <a:endParaRPr lang="en-US" sz="1350" dirty="0"/>
+          </a:p>
+        </p:txBody>
+      </p:sp>
+      <p:sp>
+        <p:nvSpPr>
+          <p:cNvPr id="18" name="Text 14"/>
+          <p:cNvSpPr/>
+          <p:nvPr/>
+        </p:nvSpPr>
+        <p:spPr>
+          <a:xfrm>
+            <a:off x="11887200" y="9710928"/>
+            <a:ext cx="5486400" cy="292608"/>
+          </a:xfrm>
+          <a:prstGeom prst="rect">
+            <a:avLst/>
+          </a:prstGeom>
+          <a:noFill/>
+          <a:ln/>
+        </p:spPr>
+        <p:txBody>
+          <a:bodyPr wrap="square" lIns="25400" tIns="25400" rIns="25400" bIns="25400" rtlCol="0" anchor="t">
+            <a:normAutofit/>
+          </a:bodyPr>
+          <a:lstStyle/>
+          <a:p>
+            <a:pPr algn="r" indent="0" marL="0">
+              <a:lnSpc>
+                <a:spcPct val="108000"/>
+              </a:lnSpc>
+              <a:buNone/>
+            </a:pPr>
+            <a:r>
+              <a:rPr lang="en-US" sz="1350" dirty="0">
+                <a:solidFill>
+                  <a:srgbClr val="969695"/>
+                </a:solidFill>
+                <a:latin typeface="Source Sans 3" pitchFamily="34" charset="0"/>
+                <a:ea typeface="Source Sans 3" pitchFamily="34" charset="-122"/>
+                <a:cs typeface="Source Sans 3" pitchFamily="34" charset="-120"/>
+              </a:rPr>
+              <a:t>Marzo 2026 · </a:t>
+            </a:r>
+            <a:fld id="{B8527E0D-ED06-472B-B01F-2E0BAEC098E6}" type="slidenum">
+              <a:rPr lang="en-US" sz="1350" dirty="0">
+                <a:solidFill>
+                  <a:srgbClr val="969695"/>
+                </a:solidFill>
+                <a:latin typeface="Source Sans 3" pitchFamily="34" charset="0"/>
+                <a:ea typeface="Source Sans 3" pitchFamily="34" charset="-122"/>
+                <a:cs typeface="Source Sans 3" pitchFamily="34" charset="-120"/>
+              </a:rPr>
+              <a:t>3</a:t>
+            </a:fld>
+            <a:endParaRPr lang="en-US" sz="1350" dirty="0"/>
+          </a:p>
+        </p:txBody>
+      </p:sp>
+    </p:spTree>
+  </p:cSld>
+  <p:clrMapOvr>
+    <a:masterClrMapping/>
+  </p:clrMapOvr>
+</p:sldLayout>
+</file>
+
+<file path=ppt/slideLayouts/slideLayout5.xml><?xml version="1.0" encoding="utf-8"?>
+<p:sldLayout xmlns:p="http://schemas.openxmlformats.org/presentationml/2006/main" xmlns:a="http://schemas.openxmlformats.org/drawingml/2006/main" xmlns:r="http://schemas.openxmlformats.org/officeDocument/2006/relationships" preserve="1" type="blank">
+  <p:cSld name="CMF En blanco">
+    <p:bg>
+      <p:bgPr>
+        <a:solidFill>
+          <a:srgbClr val="FFFFFF"/>
+        </a:solidFill>
+      </p:bgPr>
+    </p:bg>
+    <p:spTree>
+      <p:nvGrpSpPr>
+        <p:cNvPr id="1" name=""/>
+        <p:cNvGrpSpPr/>
+        <p:nvPr/>
+      </p:nvGrpSpPr>
+      <p:grpSpPr>
+        <a:xfrm>
+          <a:off x="0" y="0"/>
+          <a:ext cx="0" cy="0"/>
+          <a:chOff x="0" y="0"/>
+          <a:chExt cx="0" cy="0"/>
+        </a:xfrm>
+      </p:grpSpPr>
+      <p:sp>
+        <p:nvSpPr>
+          <p:cNvPr id="2" name="Shape 0"/>
+          <p:cNvSpPr/>
+          <p:nvPr/>
+        </p:nvSpPr>
+        <p:spPr>
+          <a:xfrm>
+            <a:off x="0" y="0"/>
+            <a:ext cx="18288000" cy="114300"/>
+          </a:xfrm>
+          <a:prstGeom prst="rect">
+            <a:avLst/>
+          </a:prstGeom>
+          <a:solidFill>
+            <a:srgbClr val="5B2B82"/>
+          </a:solidFill>
+          <a:ln/>
+        </p:spPr>
+      </p:sp>
+      <p:pic>
+        <p:nvPicPr>
+          <p:cNvPr id="3" name="Image 0" descr="preencoded.png">    </p:cNvPr>
+          <p:cNvPicPr>
+            <a:picLocks noChangeAspect="1"/>
+          </p:cNvPicPr>
+          <p:nvPr/>
+        </p:nvPicPr>
+        <p:blipFill>
+          <a:blip r:embed="rId1"/>
+          <a:stretch>
+            <a:fillRect/>
+          </a:stretch>
+        </p:blipFill>
+        <p:spPr>
+          <a:xfrm>
+            <a:off x="15772656" y="542925"/>
+            <a:ext cx="1600944" cy="485775"/>
+          </a:xfrm>
+          <a:prstGeom prst="rect">
+            <a:avLst/>
+          </a:prstGeom>
+        </p:spPr>
+      </p:pic>
+      <p:sp>
+        <p:nvSpPr>
+          <p:cNvPr id="4" name="Shape 1"/>
+          <p:cNvSpPr/>
+          <p:nvPr/>
+        </p:nvSpPr>
+        <p:spPr>
+          <a:xfrm>
+            <a:off x="914400" y="9534525"/>
+            <a:ext cx="16459200" cy="9525"/>
+          </a:xfrm>
+          <a:prstGeom prst="rect">
+            <a:avLst/>
+          </a:prstGeom>
+          <a:solidFill>
+            <a:srgbClr val="D7D7D6"/>
+          </a:solidFill>
+          <a:ln/>
+        </p:spPr>
+      </p:sp>
+      <p:pic>
+        <p:nvPicPr>
+          <p:cNvPr id="5" name="Image 1" descr="preencoded.png">    </p:cNvPr>
+          <p:cNvPicPr>
+            <a:picLocks noChangeAspect="1"/>
+          </p:cNvPicPr>
+          <p:nvPr/>
+        </p:nvPicPr>
+        <p:blipFill>
+          <a:blip r:embed="rId2"/>
+          <a:stretch>
+            <a:fillRect/>
+          </a:stretch>
+        </p:blipFill>
+        <p:spPr>
+          <a:xfrm>
+            <a:off x="914400" y="9729788"/>
+            <a:ext cx="240804" cy="228600"/>
+          </a:xfrm>
+          <a:prstGeom prst="rect">
+            <a:avLst/>
+          </a:prstGeom>
+        </p:spPr>
+      </p:pic>
+      <p:sp>
+        <p:nvSpPr>
+          <p:cNvPr id="6" name="Text 2"/>
+          <p:cNvSpPr/>
+          <p:nvPr/>
+        </p:nvSpPr>
+        <p:spPr>
+          <a:xfrm>
+            <a:off x="1289304" y="9729216"/>
+            <a:ext cx="7315200" cy="274320"/>
+          </a:xfrm>
+          <a:prstGeom prst="rect">
+            <a:avLst/>
+          </a:prstGeom>
+          <a:noFill/>
+          <a:ln/>
+        </p:spPr>
+        <p:txBody>
+          <a:bodyPr wrap="square" lIns="0" tIns="0" rIns="0" bIns="0" rtlCol="0" anchor="t">
+            <a:normAutofit/>
+          </a:bodyPr>
+          <a:lstStyle/>
+          <a:p>
+            <a:pPr algn="l" indent="0" marL="0">
+              <a:lnSpc>
+                <a:spcPct val="108000"/>
+              </a:lnSpc>
+              <a:buNone/>
+            </a:pPr>
+            <a:r>
+              <a:rPr lang="en-US" sz="1350" dirty="0">
+                <a:solidFill>
+                  <a:srgbClr val="969695"/>
+                </a:solidFill>
+                <a:latin typeface="Source Sans 3" pitchFamily="34" charset="0"/>
+                <a:ea typeface="Source Sans 3" pitchFamily="34" charset="-122"/>
+                <a:cs typeface="Source Sans 3" pitchFamily="34" charset="-120"/>
+              </a:rPr>
+              <a:t>Comisión para el Mercado Financiero</a:t>
+            </a:r>
+            <a:endParaRPr lang="en-US" sz="1350" dirty="0"/>
+          </a:p>
+        </p:txBody>
+      </p:sp>
+      <p:sp>
+        <p:nvSpPr>
+          <p:cNvPr id="7" name="Text 3"/>
+          <p:cNvSpPr/>
+          <p:nvPr/>
+        </p:nvSpPr>
+        <p:spPr>
+          <a:xfrm>
+            <a:off x="11887200" y="9710928"/>
+            <a:ext cx="5486400" cy="292608"/>
+          </a:xfrm>
+          <a:prstGeom prst="rect">
+            <a:avLst/>
+          </a:prstGeom>
+          <a:noFill/>
+          <a:ln/>
+        </p:spPr>
+        <p:txBody>
+          <a:bodyPr wrap="square" lIns="25400" tIns="25400" rIns="25400" bIns="25400" rtlCol="0" anchor="t">
+            <a:normAutofit/>
+          </a:bodyPr>
+          <a:lstStyle/>
+          <a:p>
+            <a:pPr algn="r" indent="0" marL="0">
+              <a:lnSpc>
+                <a:spcPct val="108000"/>
+              </a:lnSpc>
+              <a:buNone/>
+            </a:pPr>
+            <a:r>
+              <a:rPr lang="en-US" sz="1350" dirty="0">
+                <a:solidFill>
+                  <a:srgbClr val="969695"/>
+                </a:solidFill>
+                <a:latin typeface="Source Sans 3" pitchFamily="34" charset="0"/>
+                <a:ea typeface="Source Sans 3" pitchFamily="34" charset="-122"/>
+                <a:cs typeface="Source Sans 3" pitchFamily="34" charset="-120"/>
+              </a:rPr>
+              <a:t>Marzo 2026 · </a:t>
+            </a:r>
+            <a:fld id="{98A198A5-C19F-473F-9A80-43D657BB568F}" type="slidenum">
+              <a:rPr lang="en-US" sz="1350" dirty="0">
+                <a:solidFill>
+                  <a:srgbClr val="969695"/>
+                </a:solidFill>
+                <a:latin typeface="Source Sans 3" pitchFamily="34" charset="0"/>
+                <a:ea typeface="Source Sans 3" pitchFamily="34" charset="-122"/>
+                <a:cs typeface="Source Sans 3" pitchFamily="34" charset="-120"/>
+              </a:rPr>
+              <a:t>2</a:t>
+            </a:fld>
+            <a:endParaRPr lang="en-US" sz="1350" dirty="0"/>
+          </a:p>
+        </p:txBody>
+      </p:sp>
+    </p:spTree>
+  </p:cSld>
+  <p:clrMapOvr>
+    <a:masterClrMapping/>
+  </p:clrMapOvr>
+</p:sldLayout>
+</file>
+
 <file path=ppt/slideMasters/slideMaster1.xml><?xml version="1.0" encoding="utf-8"?>
 <p:sldMaster xmlns:a="http://schemas.openxmlformats.org/drawingml/2006/main" xmlns:r="http://schemas.openxmlformats.org/officeDocument/2006/relationships" xmlns:p="http://schemas.openxmlformats.org/presentationml/2006/main">
   <p:cSld>
@@ -774,6 +2512,10 @@
   <p:clrMap bg1="lt1" tx1="dk1" bg2="lt2" tx2="dk2" accent1="accent1" accent2="accent2" accent3="accent3" accent4="accent4" accent5="accent5" accent6="accent6" hlink="hlink" folHlink="folHlink"/>
   <p:sldLayoutIdLst>
     <p:sldLayoutId id="2147483649" r:id="rId1"/>
+    <p:sldLayoutId id="2147483652" r:id="rIdL2"/>
+    <p:sldLayoutId id="2147483653" r:id="rIdL3"/>
+    <p:sldLayoutId id="2147483654" r:id="rIdL4"/>
+    <p:sldLayoutId id="2147483655" r:id="rIdL5"/>
   </p:sldLayoutIdLst>
   <p:hf sldNum="0" hdr="0" ftr="0" dt="0"/>
   <p:txStyles>
@@ -2486,4 +4228,299 @@
     </a:ext>
   </a:extLst>
 </a:theme>
+</file>
+
+<file path=ppt/theme/theme2.xml><?xml version="1.0" encoding="utf-8"?>
+<a:theme xmlns:a="http://schemas.openxmlformats.org/drawingml/2006/main" name="Office Theme Notas">
+  <a:themeElements>
+    <a:clrScheme name="Office">
+      <a:dk1>
+        <a:sysClr val="windowText" lastClr="000000"/>
+      </a:dk1>
+      <a:lt1>
+        <a:sysClr val="window" lastClr="FFFFFF"/>
+      </a:lt1>
+      <a:dk2>
+        <a:srgbClr val="44546A"/>
+      </a:dk2>
+      <a:lt2>
+        <a:srgbClr val="E7E6E6"/>
+      </a:lt2>
+      <a:accent1>
+        <a:srgbClr val="4472C4"/>
+      </a:accent1>
+      <a:accent2>
+        <a:srgbClr val="ED7D31"/>
+      </a:accent2>
+      <a:accent3>
+        <a:srgbClr val="A5A5A5"/>
+      </a:accent3>
+      <a:accent4>
+        <a:srgbClr val="FFC000"/>
+      </a:accent4>
+      <a:accent5>
+        <a:srgbClr val="5B9BD5"/>
+      </a:accent5>
+      <a:accent6>
+        <a:srgbClr val="70AD47"/>
+      </a:accent6>
+      <a:hlink>
+        <a:srgbClr val="0563C1"/>
+      </a:hlink>
+      <a:folHlink>
+        <a:srgbClr val="954F72"/>
+      </a:folHlink>
+    </a:clrScheme>
+    <a:fontScheme name="Office">
+      <a:majorFont>
+        <a:latin typeface="Calibri Light" panose="020F0302020204030204"/>
+        <a:ea typeface=""/>
+        <a:cs typeface=""/>
+        <a:font script="Jpan" typeface="游ゴシック Light"/>
+        <a:font script="Hang" typeface="맑은 고딕"/>
+        <a:font script="Hans" typeface="等线 Light"/>
+        <a:font script="Hant" typeface="新細明體"/>
+        <a:font script="Arab" typeface="Times New Roman"/>
+        <a:font script="Hebr" typeface="Times New Roman"/>
+        <a:font script="Thai" typeface="Angsana New"/>
+        <a:font script="Ethi" typeface="Nyala"/>
+        <a:font script="Beng" typeface="Vrinda"/>
+        <a:font script="Gujr" typeface="Shruti"/>
+        <a:font script="Khmr" typeface="MoolBoran"/>
+        <a:font script="Knda" typeface="Tunga"/>
+        <a:font script="Guru" typeface="Raavi"/>
+        <a:font script="Cans" typeface="Euphemia"/>
+        <a:font script="Cher" typeface="Plantagenet Cherokee"/>
+        <a:font script="Yiii" typeface="Microsoft Yi Baiti"/>
+        <a:font script="Tibt" typeface="Microsoft Himalaya"/>
+        <a:font script="Thaa" typeface="MV Boli"/>
+        <a:font script="Deva" typeface="Mangal"/>
+        <a:font script="Telu" typeface="Gautami"/>
+        <a:font script="Taml" typeface="Latha"/>
+        <a:font script="Syrc" typeface="Estrangelo Edessa"/>
+        <a:font script="Orya" typeface="Kalinga"/>
+        <a:font script="Mlym" typeface="Kartika"/>
+        <a:font script="Laoo" typeface="DokChampa"/>
+        <a:font script="Sinh" typeface="Iskoola Pota"/>
+        <a:font script="Mong" typeface="Mongolian Baiti"/>
+        <a:font script="Viet" typeface="Times New Roman"/>
+        <a:font script="Uigh" typeface="Microsoft Uighur"/>
+        <a:font script="Geor" typeface="Sylfaen"/>
+        <a:font script="Armn" typeface="Arial"/>
+        <a:font script="Bugi" typeface="Leelawadee UI"/>
+        <a:font script="Bopo" typeface="Microsoft JhengHei"/>
+        <a:font script="Java" typeface="Javanese Text"/>
+        <a:font script="Lisu" typeface="Segoe UI"/>
+        <a:font script="Mymr" typeface="Myanmar Text"/>
+        <a:font script="Nkoo" typeface="Ebrima"/>
+        <a:font script="Olck" typeface="Nirmala UI"/>
+        <a:font script="Osma" typeface="Ebrima"/>
+        <a:font script="Phag" typeface="Phagspa"/>
+        <a:font script="Syrn" typeface="Estrangelo Edessa"/>
+        <a:font script="Syrj" typeface="Estrangelo Edessa"/>
+        <a:font script="Syre" typeface="Estrangelo Edessa"/>
+        <a:font script="Sora" typeface="Nirmala UI"/>
+        <a:font script="Tale" typeface="Microsoft Tai Le"/>
+        <a:font script="Talu" typeface="Microsoft New Tai Lue"/>
+        <a:font script="Tfng" typeface="Ebrima"/>
+      </a:majorFont>
+      <a:minorFont>
+        <a:latin typeface="Calibri" panose="020F0502020204030204"/>
+        <a:ea typeface=""/>
+        <a:cs typeface=""/>
+        <a:font script="Jpan" typeface="游ゴシック"/>
+        <a:font script="Hang" typeface="맑은 고딕"/>
+        <a:font script="Hans" typeface="等线"/>
+        <a:font script="Hant" typeface="新細明體"/>
+        <a:font script="Arab" typeface="Arial"/>
+        <a:font script="Hebr" typeface="Arial"/>
+        <a:font script="Thai" typeface="Cordia New"/>
+        <a:font script="Ethi" typeface="Nyala"/>
+        <a:font script="Beng" typeface="Vrinda"/>
+        <a:font script="Gujr" typeface="Shruti"/>
+        <a:font script="Khmr" typeface="DaunPenh"/>
+        <a:font script="Knda" typeface="Tunga"/>
+        <a:font script="Guru" typeface="Raavi"/>
+        <a:font script="Cans" typeface="Euphemia"/>
+        <a:font script="Cher" typeface="Plantagenet Cherokee"/>
+        <a:font script="Yiii" typeface="Microsoft Yi Baiti"/>
+        <a:font script="Tibt" typeface="Microsoft Himalaya"/>
+        <a:font script="Thaa" typeface="MV Boli"/>
+        <a:font script="Deva" typeface="Mangal"/>
+        <a:font script="Telu" typeface="Gautami"/>
+        <a:font script="Taml" typeface="Latha"/>
+        <a:font script="Syrc" typeface="Estrangelo Edessa"/>
+        <a:font script="Orya" typeface="Kalinga"/>
+        <a:font script="Mlym" typeface="Kartika"/>
+        <a:font script="Laoo" typeface="DokChampa"/>
+        <a:font script="Sinh" typeface="Iskoola Pota"/>
+        <a:font script="Mong" typeface="Mongolian Baiti"/>
+        <a:font script="Viet" typeface="Arial"/>
+        <a:font script="Uigh" typeface="Microsoft Uighur"/>
+        <a:font script="Geor" typeface="Sylfaen"/>
+        <a:font script="Armn" typeface="Arial"/>
+        <a:font script="Bugi" typeface="Leelawadee UI"/>
+        <a:font script="Bopo" typeface="Microsoft JhengHei"/>
+        <a:font script="Java" typeface="Javanese Text"/>
+        <a:font script="Lisu" typeface="Segoe UI"/>
+        <a:font script="Mymr" typeface="Myanmar Text"/>
+        <a:font script="Nkoo" typeface="Ebrima"/>
+        <a:font script="Olck" typeface="Nirmala UI"/>
+        <a:font script="Osma" typeface="Ebrima"/>
+        <a:font script="Phag" typeface="Phagspa"/>
+        <a:font script="Syrn" typeface="Estrangelo Edessa"/>
+        <a:font script="Syrj" typeface="Estrangelo Edessa"/>
+        <a:font script="Syre" typeface="Estrangelo Edessa"/>
+        <a:font script="Sora" typeface="Nirmala UI"/>
+        <a:font script="Tale" typeface="Microsoft Tai Le"/>
+        <a:font script="Talu" typeface="Microsoft New Tai Lue"/>
+        <a:font script="Tfng" typeface="Ebrima"/>
+      </a:minorFont>
+    </a:fontScheme>
+    <a:fmtScheme name="Office">
+      <a:fillStyleLst>
+        <a:solidFill>
+          <a:schemeClr val="phClr"/>
+        </a:solidFill>
+        <a:gradFill rotWithShape="1">
+          <a:gsLst>
+            <a:gs pos="0">
+              <a:schemeClr val="phClr">
+                <a:lumMod val="110000"/>
+                <a:satMod val="105000"/>
+                <a:tint val="67000"/>
+              </a:schemeClr>
+            </a:gs>
+            <a:gs pos="50000">
+              <a:schemeClr val="phClr">
+                <a:lumMod val="105000"/>
+                <a:satMod val="103000"/>
+                <a:tint val="73000"/>
+              </a:schemeClr>
+            </a:gs>
+            <a:gs pos="100000">
+              <a:schemeClr val="phClr">
+                <a:lumMod val="105000"/>
+                <a:satMod val="109000"/>
+                <a:tint val="81000"/>
+              </a:schemeClr>
+            </a:gs>
+          </a:gsLst>
+          <a:lin ang="5400000" scaled="0"/>
+        </a:gradFill>
+        <a:gradFill rotWithShape="1">
+          <a:gsLst>
+            <a:gs pos="0">
+              <a:schemeClr val="phClr">
+                <a:satMod val="103000"/>
+                <a:lumMod val="102000"/>
+                <a:tint val="94000"/>
+              </a:schemeClr>
+            </a:gs>
+            <a:gs pos="50000">
+              <a:schemeClr val="phClr">
+                <a:satMod val="110000"/>
+                <a:lumMod val="100000"/>
+                <a:shade val="100000"/>
+              </a:schemeClr>
+            </a:gs>
+            <a:gs pos="100000">
+              <a:schemeClr val="phClr">
+                <a:lumMod val="99000"/>
+                <a:satMod val="120000"/>
+                <a:shade val="78000"/>
+              </a:schemeClr>
+            </a:gs>
+          </a:gsLst>
+          <a:lin ang="5400000" scaled="0"/>
+        </a:gradFill>
+      </a:fillStyleLst>
+      <a:lnStyleLst>
+        <a:ln w="6350" cap="flat" cmpd="sng" algn="ctr">
+          <a:solidFill>
+            <a:schemeClr val="phClr"/>
+          </a:solidFill>
+          <a:prstDash val="solid"/>
+          <a:miter lim="800000"/>
+        </a:ln>
+        <a:ln w="12700" cap="flat" cmpd="sng" algn="ctr">
+          <a:solidFill>
+            <a:schemeClr val="phClr"/>
+          </a:solidFill>
+          <a:prstDash val="solid"/>
+          <a:miter lim="800000"/>
+        </a:ln>
+        <a:ln w="19050" cap="flat" cmpd="sng" algn="ctr">
+          <a:solidFill>
+            <a:schemeClr val="phClr"/>
+          </a:solidFill>
+          <a:prstDash val="solid"/>
+          <a:miter lim="800000"/>
+        </a:ln>
+      </a:lnStyleLst>
+      <a:effectStyleLst>
+        <a:effectStyle>
+          <a:effectLst/>
+        </a:effectStyle>
+        <a:effectStyle>
+          <a:effectLst/>
+        </a:effectStyle>
+        <a:effectStyle>
+          <a:effectLst>
+            <a:outerShdw blurRad="57150" dist="19050" dir="5400000" algn="ctr" rotWithShape="0">
+              <a:srgbClr val="000000">
+                <a:alpha val="63000"/>
+              </a:srgbClr>
+            </a:outerShdw>
+          </a:effectLst>
+        </a:effectStyle>
+      </a:effectStyleLst>
+      <a:bgFillStyleLst>
+        <a:solidFill>
+          <a:schemeClr val="phClr"/>
+        </a:solidFill>
+        <a:solidFill>
+          <a:schemeClr val="phClr">
+            <a:tint val="95000"/>
+            <a:satMod val="170000"/>
+          </a:schemeClr>
+        </a:solidFill>
+        <a:gradFill rotWithShape="1">
+          <a:gsLst>
+            <a:gs pos="0">
+              <a:schemeClr val="phClr">
+                <a:tint val="93000"/>
+                <a:satMod val="150000"/>
+                <a:shade val="98000"/>
+                <a:lumMod val="102000"/>
+              </a:schemeClr>
+            </a:gs>
+            <a:gs pos="50000">
+              <a:schemeClr val="phClr">
+                <a:tint val="98000"/>
+                <a:satMod val="130000"/>
+                <a:shade val="90000"/>
+                <a:lumMod val="103000"/>
+              </a:schemeClr>
+            </a:gs>
+            <a:gs pos="100000">
+              <a:schemeClr val="phClr">
+                <a:shade val="63000"/>
+                <a:satMod val="120000"/>
+              </a:schemeClr>
+            </a:gs>
+          </a:gsLst>
+          <a:lin ang="5400000" scaled="0"/>
+        </a:gradFill>
+      </a:bgFillStyleLst>
+    </a:fmtScheme>
+  </a:themeElements>
+  <a:objectDefaults/>
+  <a:extraClrSchemeLst/>
+  <a:extLst>
+    <a:ext uri="{05A4C25C-085E-4340-85A3-A5531E510DB2}">
+      <thm15:themeFamily xmlns:thm15="http://schemas.microsoft.com/office/thememl/2012/main" name="Office Theme" id="{62F939B6-93AF-4DB8-9C6B-D6C7DFDC589F}" vid="{4A3C46E8-61CC-4603-A589-7422A47A8E4A}"/>
+    </a:ext>
+  </a:extLst>
+</a:theme>
 </file>
</xml_diff>

<commit_message>
Agrega el diseño CMF Separador a la plantilla 2026
Corte de bloque a sangre sobre fondo institucional, con el número del
bloque como marca de agua, la tipografía en blanco y el logo en su
versión blanca.

CMF Sección se conserva sin cambios: proyectado se confunde con una
lámina de contenido, que es el problema que este diseño resuelve, pero
reemplazarlo rompería las presentaciones que ya lo usan.

El número del bloque es un marcador que se escribe a mano, porque
PowerPoint no tiene contador de secciones. La bajada es opcional.
</commit_message>
<xml_diff>
--- a/guidelines/CMF-plantilla-2026.pptx
+++ b/guidelines/CMF-plantilla-2026.pptx
@@ -1154,7 +1154,7 @@
               </a:lnSpc>
               <a:buNone/>
             </a:pPr>
-            <a:fld id="{B5E4E44B-B729-4933-9576-2397FE414F70}" type="slidenum">
+            <a:fld id="{EA582884-136E-4DE1-9188-DA0349807FE5}" type="slidenum">
               <a:rPr lang="en-US" sz="1200" dirty="0">
                 <a:solidFill>
                   <a:srgbClr val="FFFFFF">
@@ -1519,7 +1519,7 @@
               </a:rPr>
               <a:t>Marzo 2026 · </a:t>
             </a:r>
-            <a:fld id="{296237B6-5E3F-4A53-8617-0B6476DA17E1}" type="slidenum">
+            <a:fld id="{218D0039-912B-421F-87CD-0FAC6475F823}" type="slidenum">
               <a:rPr lang="en-US" sz="1350" dirty="0">
                 <a:solidFill>
                   <a:srgbClr val="969695"/>
@@ -2248,7 +2248,7 @@
               </a:rPr>
               <a:t>Marzo 2026 · </a:t>
             </a:r>
-            <a:fld id="{B8527E0D-ED06-472B-B01F-2E0BAEC098E6}" type="slidenum">
+            <a:fld id="{BBFADF48-F6C2-42CE-A217-E5975670DAB2}" type="slidenum">
               <a:rPr lang="en-US" sz="1350" dirty="0">
                 <a:solidFill>
                   <a:srgbClr val="969695"/>
@@ -2467,7 +2467,7 @@
               </a:rPr>
               <a:t>Marzo 2026 · </a:t>
             </a:r>
-            <a:fld id="{98A198A5-C19F-473F-9A80-43D657BB568F}" type="slidenum">
+            <a:fld id="{5013A543-B1DB-41B9-8256-8791F49E8128}" type="slidenum">
               <a:rPr lang="en-US" sz="1350" dirty="0">
                 <a:solidFill>
                   <a:srgbClr val="969695"/>
@@ -2479,6 +2479,279 @@
               <a:t>2</a:t>
             </a:fld>
             <a:endParaRPr lang="en-US" sz="1350" dirty="0"/>
+          </a:p>
+        </p:txBody>
+      </p:sp>
+    </p:spTree>
+  </p:cSld>
+  <p:clrMapOvr>
+    <a:masterClrMapping/>
+  </p:clrMapOvr>
+</p:sldLayout>
+</file>
+
+<file path=ppt/slideLayouts/slideLayout6.xml><?xml version="1.0" encoding="utf-8"?>
+<p:sldLayout xmlns:a="http://schemas.openxmlformats.org/drawingml/2006/main" xmlns:r="http://schemas.openxmlformats.org/officeDocument/2006/relationships" xmlns:p="http://schemas.openxmlformats.org/presentationml/2006/main" preserve="1" type="secHead">
+  <p:cSld name="CMF Separador">
+    <p:spTree>
+      <p:nvGrpSpPr>
+        <p:cNvPr id="1" name=""/>
+        <p:cNvGrpSpPr/>
+        <p:nvPr/>
+      </p:nvGrpSpPr>
+      <p:grpSpPr/>
+      <p:sp>
+        <p:nvSpPr>
+          <p:cNvPr id="2" name="Fondo"/>
+          <p:cNvSpPr/>
+          <p:nvPr/>
+        </p:nvSpPr>
+        <p:spPr>
+          <a:xfrm>
+            <a:off x="0" y="0"/>
+            <a:ext cx="18288000" cy="10287000"/>
+          </a:xfrm>
+          <a:prstGeom prst="rect">
+            <a:avLst/>
+          </a:prstGeom>
+          <a:solidFill>
+            <a:srgbClr val="162C55"/>
+          </a:solidFill>
+          <a:ln>
+            <a:noFill/>
+          </a:ln>
+        </p:spPr>
+      </p:sp>
+      <p:sp>
+        <p:nvSpPr>
+          <p:cNvPr id="3" name="Numero"/>
+          <p:cNvSpPr/>
+          <p:nvPr>
+            <p:ph type="body" idx="4"/>
+          </p:nvPr>
+        </p:nvSpPr>
+        <p:spPr>
+          <a:xfrm>
+            <a:off x="12252960" y="960120"/>
+            <a:ext cx="4754880" cy="4754880"/>
+          </a:xfrm>
+          <a:prstGeom prst="rect">
+            <a:avLst/>
+          </a:prstGeom>
+          <a:noFill/>
+        </p:spPr>
+        <p:txBody>
+          <a:bodyPr wrap="square" lIns="0" tIns="0" rIns="0" bIns="0" anchor="t"/>
+          <a:lstStyle>
+            <a:lvl1pPr algn="r" marL="0" indent="0">
+              <a:buNone/>
+              <a:defRPr sz="21000" b="1">
+                <a:solidFill>
+                  <a:srgbClr val="3F3A7E"/>
+                </a:solidFill>
+                <a:latin typeface="Verdana"/>
+              </a:defRPr>
+            </a:lvl1pPr>
+          </a:lstStyle>
+          <a:p>
+            <a:pPr algn="r">
+              <a:buNone/>
+            </a:pPr>
+            <a:endParaRPr/>
+          </a:p>
+        </p:txBody>
+      </p:sp>
+      <p:sp>
+        <p:nvSpPr>
+          <p:cNvPr id="4" name="Antetitulo"/>
+          <p:cNvSpPr/>
+          <p:nvPr>
+            <p:ph type="body" idx="1"/>
+          </p:nvPr>
+        </p:nvSpPr>
+        <p:spPr>
+          <a:xfrm>
+            <a:off x="1280160" y="3794760"/>
+            <a:ext cx="10058400" cy="365760"/>
+          </a:xfrm>
+          <a:prstGeom prst="rect">
+            <a:avLst/>
+          </a:prstGeom>
+          <a:noFill/>
+        </p:spPr>
+        <p:txBody>
+          <a:bodyPr wrap="square" lIns="0" tIns="0" rIns="0" bIns="0" anchor="t"/>
+          <a:lstStyle>
+            <a:lvl1pPr algn="l" marL="0" indent="0">
+              <a:buNone/>
+              <a:defRPr sz="1575" b="1" cap="all">
+                <a:solidFill>
+                  <a:srgbClr val="97D6D2"/>
+                </a:solidFill>
+                <a:latin typeface="Source Sans 3"/>
+              </a:defRPr>
+            </a:lvl1pPr>
+          </a:lstStyle>
+          <a:p>
+            <a:pPr algn="l">
+              <a:buNone/>
+            </a:pPr>
+            <a:endParaRPr/>
+          </a:p>
+        </p:txBody>
+      </p:sp>
+      <p:sp>
+        <p:nvSpPr>
+          <p:cNvPr id="5" name="Regla"/>
+          <p:cNvSpPr/>
+          <p:nvPr/>
+        </p:nvSpPr>
+        <p:spPr>
+          <a:xfrm>
+            <a:off x="1280160" y="4453128"/>
+            <a:ext cx="1463040" cy="91440"/>
+          </a:xfrm>
+          <a:prstGeom prst="rect">
+            <a:avLst/>
+          </a:prstGeom>
+          <a:solidFill>
+            <a:srgbClr val="8547AD"/>
+          </a:solidFill>
+          <a:ln>
+            <a:noFill/>
+          </a:ln>
+        </p:spPr>
+      </p:sp>
+      <p:sp>
+        <p:nvSpPr>
+          <p:cNvPr id="6" name="Titulo"/>
+          <p:cNvSpPr/>
+          <p:nvPr>
+            <p:ph type="title"/>
+          </p:nvPr>
+        </p:nvSpPr>
+        <p:spPr>
+          <a:xfrm>
+            <a:off x="1280160" y="4846320"/>
+            <a:ext cx="10058400" cy="1554480"/>
+          </a:xfrm>
+          <a:prstGeom prst="rect">
+            <a:avLst/>
+          </a:prstGeom>
+          <a:noFill/>
+        </p:spPr>
+        <p:txBody>
+          <a:bodyPr wrap="square" lIns="0" tIns="0" rIns="0" bIns="0" anchor="t"/>
+          <a:lstStyle>
+            <a:lvl1pPr algn="l" marL="0" indent="0">
+              <a:buNone/>
+              <a:defRPr sz="5200" b="1">
+                <a:solidFill>
+                  <a:srgbClr val="FFFFFF"/>
+                </a:solidFill>
+                <a:latin typeface="Verdana"/>
+              </a:defRPr>
+            </a:lvl1pPr>
+          </a:lstStyle>
+          <a:p>
+            <a:pPr algn="l">
+              <a:buNone/>
+            </a:pPr>
+            <a:endParaRPr/>
+          </a:p>
+        </p:txBody>
+      </p:sp>
+      <p:sp>
+        <p:nvSpPr>
+          <p:cNvPr id="7" name="Bajada"/>
+          <p:cNvSpPr/>
+          <p:nvPr>
+            <p:ph type="body" idx="2"/>
+          </p:nvPr>
+        </p:nvSpPr>
+        <p:spPr>
+          <a:xfrm>
+            <a:off x="1280160" y="6812280"/>
+            <a:ext cx="9692640" cy="1188720"/>
+          </a:xfrm>
+          <a:prstGeom prst="rect">
+            <a:avLst/>
+          </a:prstGeom>
+          <a:noFill/>
+        </p:spPr>
+        <p:txBody>
+          <a:bodyPr wrap="square" lIns="0" tIns="0" rIns="0" bIns="0" anchor="t"/>
+          <a:lstStyle>
+            <a:lvl1pPr algn="l" marL="0" indent="0">
+              <a:buNone/>
+              <a:defRPr sz="1800">
+                <a:solidFill>
+                  <a:srgbClr val="97D6D2"/>
+                </a:solidFill>
+                <a:latin typeface="Source Sans 3"/>
+              </a:defRPr>
+            </a:lvl1pPr>
+          </a:lstStyle>
+          <a:p>
+            <a:pPr algn="l">
+              <a:buNone/>
+            </a:pPr>
+            <a:endParaRPr/>
+          </a:p>
+        </p:txBody>
+      </p:sp>
+      <p:pic>
+        <p:nvPicPr>
+          <p:cNvPr id="8" name="Logo"/>
+          <p:cNvPicPr/>
+          <p:nvPr/>
+        </p:nvPicPr>
+        <p:blipFill>
+          <a:blip r:embed="rIdLogo"/>
+          <a:stretch>
+            <a:fillRect/>
+          </a:stretch>
+        </p:blipFill>
+        <p:spPr>
+          <a:xfrm>
+            <a:off x="1280160" y="8549640"/>
+            <a:ext cx="2412336" cy="566928"/>
+          </a:xfrm>
+          <a:prstGeom prst="rect">
+            <a:avLst/>
+          </a:prstGeom>
+        </p:spPr>
+      </p:pic>
+      <p:sp>
+        <p:nvSpPr>
+          <p:cNvPr id="9" name="Folio"/>
+          <p:cNvSpPr txBox="1"/>
+          <p:nvPr/>
+        </p:nvSpPr>
+        <p:spPr>
+          <a:xfrm>
+            <a:off x="11887200" y="8796528"/>
+            <a:ext cx="5486400" cy="310896"/>
+          </a:xfrm>
+          <a:prstGeom prst="rect">
+            <a:avLst/>
+          </a:prstGeom>
+          <a:noFill/>
+        </p:spPr>
+        <p:txBody>
+          <a:bodyPr wrap="square" lIns="0" tIns="0" rIns="0" bIns="0"/>
+          <a:lstStyle/>
+          <a:p>
+            <a:pPr algn="r"/>
+            <a:fld id="{48E3CD97-923D-4D67-A203-2AB031981B28}" type="slidenum">
+              <a:rPr lang="es-CL" sz="1200">
+                <a:solidFill>
+                  <a:srgbClr val="D7D7D6"/>
+                </a:solidFill>
+                <a:latin typeface="Source Sans 3"/>
+              </a:rPr>
+              <a:t>2</a:t>
+            </a:fld>
           </a:p>
         </p:txBody>
       </p:sp>
@@ -2516,6 +2789,7 @@
     <p:sldLayoutId id="2147483653" r:id="rIdL3"/>
     <p:sldLayoutId id="2147483654" r:id="rIdL4"/>
     <p:sldLayoutId id="2147483655" r:id="rIdL5"/>
+    <p:sldLayoutId id="2147483656" r:id="rIdL6"/>
   </p:sldLayoutIdLst>
   <p:hf sldNum="0" hdr="0" ftr="0" dt="0"/>
   <p:txStyles>

</xml_diff>

<commit_message>
Reescribe las propiedades del documento al generar la plantilla
PowerPoint compara lo que declara docProps/app.xml —cuántas diapositivas,
con qué títulos, qué tema— contra el contenido real del archivo, y pide
repararlo si no calzan. Al agregar el tema del patrón de notas, esa
declaración dejó de corresponder.

Es el mismo defecto que aparece al generar presentaciones desde la
plantilla con herramientas que no actualizan esas propiedades.
</commit_message>
<xml_diff>
--- a/guidelines/CMF-plantilla-2026.pptx
+++ b/guidelines/CMF-plantilla-2026.pptx
@@ -1154,7 +1154,7 @@
               </a:lnSpc>
               <a:buNone/>
             </a:pPr>
-            <a:fld id="{EA582884-136E-4DE1-9188-DA0349807FE5}" type="slidenum">
+            <a:fld id="{9EBC56F6-7EC8-4C52-96F4-6B5BB50A2EF3}" type="slidenum">
               <a:rPr lang="en-US" sz="1200" dirty="0">
                 <a:solidFill>
                   <a:srgbClr val="FFFFFF">
@@ -1519,7 +1519,7 @@
               </a:rPr>
               <a:t>Marzo 2026 · </a:t>
             </a:r>
-            <a:fld id="{218D0039-912B-421F-87CD-0FAC6475F823}" type="slidenum">
+            <a:fld id="{201E33D4-A69F-43E0-958C-51F3B5B92960}" type="slidenum">
               <a:rPr lang="en-US" sz="1350" dirty="0">
                 <a:solidFill>
                   <a:srgbClr val="969695"/>
@@ -2248,7 +2248,7 @@
               </a:rPr>
               <a:t>Marzo 2026 · </a:t>
             </a:r>
-            <a:fld id="{BBFADF48-F6C2-42CE-A217-E5975670DAB2}" type="slidenum">
+            <a:fld id="{387E7632-27A4-47AC-BF97-389FCA0804B8}" type="slidenum">
               <a:rPr lang="en-US" sz="1350" dirty="0">
                 <a:solidFill>
                   <a:srgbClr val="969695"/>
@@ -2467,7 +2467,7 @@
               </a:rPr>
               <a:t>Marzo 2026 · </a:t>
             </a:r>
-            <a:fld id="{5013A543-B1DB-41B9-8256-8791F49E8128}" type="slidenum">
+            <a:fld id="{3D711F8A-CBC7-44F2-A0CF-4489B9088FB4}" type="slidenum">
               <a:rPr lang="en-US" sz="1350" dirty="0">
                 <a:solidFill>
                   <a:srgbClr val="969695"/>
@@ -2743,7 +2743,7 @@
           <a:lstStyle/>
           <a:p>
             <a:pPr algn="r"/>
-            <a:fld id="{48E3CD97-923D-4D67-A203-2AB031981B28}" type="slidenum">
+            <a:fld id="{A629DC97-EA9D-4BD7-8512-A752779A19D7}" type="slidenum">
               <a:rPr lang="es-CL" sz="1200">
                 <a:solidFill>
                   <a:srgbClr val="D7D7D6"/>

</xml_diff>